<commit_message>
Add drone/3D-site future direction and story hooks to the deck
New slide 13 'La prochaine histoire': drone photogrammetry for 3D
site reconstruction, tied to the existing headless 3D report engine
and the STM32 flight-controller background, with a photogrammetry
pilot added to month 3 of the internship plan. Each project slide
now opens with a one-line narrative hook.

Co-Authored-By: Claude Fable 5 <noreply@anthropic.com>
Claude-Session: https://claude.ai/code/session_013n5yGsQZkeJ42KLHNXV8Vp
</commit_message>
<xml_diff>
--- a/presentations/svt-le-switch-a-500.pptx
+++ b/presentations/svt-le-switch-a-500.pptx
@@ -19,9 +19,10 @@
     <p:sldId id="267" r:id="rId13"/>
     <p:sldId id="268" r:id="rId14"/>
     <p:sldId id="269" r:id="rId15"/>
+    <p:sldId id="270" r:id="rId16"/>
   </p:sldIdLst>
   <p:notesMasterIdLst>
-    <p:notesMasterId r:id="rId16"/>
+    <p:notesMasterId r:id="rId17"/>
   </p:notesMasterIdLst>
   <p:sldSz cx="12192000" cy="6858000"/>
   <p:notesSz cx="6858000" cy="12192000"/>
@@ -979,6 +980,94 @@
             <a:fld id="{F7021451-1387-4CA6-816F-3879F97B5CBC}" type="slidenum">
               <a:rPr lang="en-US"/>
               <a:t>14</a:t>
+            </a:fld>
+            <a:endParaRPr lang="en-US"/>
+          </a:p>
+        </p:txBody>
+      </p:sp>
+    </p:spTree>
+    <p:extLst>
+      <p:ext uri="{BB962C8B-B14F-4D97-AF65-F5344CB8AC3E}">
+        <p14:creationId xmlns:p14="http://schemas.microsoft.com/office/powerpoint/2010/main" val="1024086991"/>
+      </p:ext>
+    </p:extLst>
+  </p:cSld>
+  <p:clrMapOvr>
+    <a:masterClrMapping/>
+  </p:clrMapOvr>
+</p:notes>
+</file>
+
+<file path=ppt/notesSlides/notesSlide15.xml><?xml version="1.0" encoding="utf-8"?>
+<p:notes xmlns:a="http://schemas.openxmlformats.org/drawingml/2006/main" xmlns:r="http://schemas.openxmlformats.org/officeDocument/2006/relationships" xmlns:p="http://schemas.openxmlformats.org/presentationml/2006/main">
+  <p:cSld>
+    <p:spTree>
+      <p:nvGrpSpPr>
+        <p:cNvPr id="1" name=""/>
+        <p:cNvGrpSpPr/>
+        <p:nvPr/>
+      </p:nvGrpSpPr>
+      <p:grpSpPr>
+        <a:xfrm>
+          <a:off x="0" y="0"/>
+          <a:ext cx="0" cy="0"/>
+          <a:chOff x="0" y="0"/>
+          <a:chExt cx="0" cy="0"/>
+        </a:xfrm>
+      </p:grpSpPr>
+      <p:sp>
+        <p:nvSpPr>
+          <p:cNvPr id="2" name="Slide Image Placeholder 1"/>
+          <p:cNvSpPr>
+            <a:spLocks noGrp="1" noRot="1" noChangeAspect="1"/>
+          </p:cNvSpPr>
+          <p:nvPr>
+            <p:ph type="sldImg"/>
+          </p:nvPr>
+        </p:nvSpPr>
+        <p:spPr/>
+      </p:sp>
+      <p:sp>
+        <p:nvSpPr>
+          <p:cNvPr id="3" name="Notes Placeholder 2"/>
+          <p:cNvSpPr>
+            <a:spLocks noGrp="1"/>
+          </p:cNvSpPr>
+          <p:nvPr>
+            <p:ph type="body" idx="1"/>
+          </p:nvPr>
+        </p:nvSpPr>
+        <p:spPr/>
+        <p:txBody>
+          <a:bodyPr/>
+          <a:lstStyle/>
+          <a:p>
+            <a:r>
+              <a:rPr lang="en-US" dirty="0"/>
+              <a:t/>
+            </a:r>
+            <a:endParaRPr lang="en-US" dirty="0"/>
+          </a:p>
+        </p:txBody>
+      </p:sp>
+      <p:sp>
+        <p:nvSpPr>
+          <p:cNvPr id="4" name="Slide Number Placeholder 3"/>
+          <p:cNvSpPr>
+            <a:spLocks noGrp="1"/>
+          </p:cNvSpPr>
+          <p:nvPr>
+            <p:ph type="sldNum" sz="quarter" idx="10"/>
+          </p:nvPr>
+        </p:nvSpPr>
+        <p:spPr/>
+        <p:txBody>
+          <a:bodyPr/>
+          <a:lstStyle/>
+          <a:p>
+            <a:fld id="{F7021451-1387-4CA6-816F-3879F97B5CBC}" type="slidenum">
+              <a:rPr lang="en-US"/>
+              <a:t>15</a:t>
             </a:fld>
             <a:endParaRPr lang="en-US"/>
           </a:p>
@@ -2905,14 +2994,53 @@
       </p:sp>
       <p:sp>
         <p:nvSpPr>
-          <p:cNvPr id="6" name="Shape 4"/>
-          <p:cNvSpPr/>
-          <p:nvPr/>
-        </p:nvSpPr>
-        <p:spPr>
-          <a:xfrm>
-            <a:off x="502920" y="1463040"/>
-            <a:ext cx="3675888" cy="4343400"/>
+          <p:cNvPr id="6" name="Text 4"/>
+          <p:cNvSpPr/>
+          <p:nvPr/>
+        </p:nvSpPr>
+        <p:spPr>
+          <a:xfrm>
+            <a:off x="502920" y="1298448"/>
+            <a:ext cx="11155680" cy="457200"/>
+          </a:xfrm>
+          <a:prstGeom prst="rect">
+            <a:avLst/>
+          </a:prstGeom>
+          <a:noFill/>
+          <a:ln/>
+        </p:spPr>
+        <p:txBody>
+          <a:bodyPr wrap="square" lIns="0" tIns="0" rIns="0" bIns="0" rtlCol="0" anchor="ctr"/>
+          <a:lstStyle/>
+          <a:p>
+            <a:pPr indent="0" marL="0">
+              <a:buNone/>
+            </a:pPr>
+            <a:r>
+              <a:rPr lang="en-US" sz="1350" dirty="0">
+                <a:solidFill>
+                  <a:srgbClr val="9DB2C7"/>
+                </a:solidFill>
+                <a:latin typeface="Calibri" pitchFamily="34" charset="0"/>
+                <a:ea typeface="Calibri" pitchFamily="34" charset="-122"/>
+                <a:cs typeface="Calibri" pitchFamily="34" charset="-120"/>
+              </a:rPr>
+              <a:t>Trois UC à mettre à jour = trois clés USB et une matinée — ou un seul geste, depuis un navigateur.</a:t>
+            </a:r>
+            <a:endParaRPr lang="en-US" sz="1350" dirty="0"/>
+          </a:p>
+        </p:txBody>
+      </p:sp>
+      <p:sp>
+        <p:nvSpPr>
+          <p:cNvPr id="7" name="Shape 5"/>
+          <p:cNvSpPr/>
+          <p:nvPr/>
+        </p:nvSpPr>
+        <p:spPr>
+          <a:xfrm>
+            <a:off x="502920" y="1783080"/>
+            <a:ext cx="3675888" cy="4023360"/>
           </a:xfrm>
           <a:prstGeom prst="roundRect">
             <a:avLst>
@@ -2932,13 +3060,13 @@
       </p:sp>
       <p:sp>
         <p:nvSpPr>
-          <p:cNvPr id="7" name="Shape 5"/>
-          <p:cNvSpPr/>
-          <p:nvPr/>
-        </p:nvSpPr>
-        <p:spPr>
-          <a:xfrm>
-            <a:off x="731520" y="1664208"/>
+          <p:cNvPr id="8" name="Shape 6"/>
+          <p:cNvSpPr/>
+          <p:nvPr/>
+        </p:nvSpPr>
+        <p:spPr>
+          <a:xfrm>
+            <a:off x="731520" y="1984248"/>
             <a:ext cx="1371600" cy="310896"/>
           </a:xfrm>
           <a:prstGeom prst="roundRect">
@@ -2954,13 +3082,13 @@
       </p:sp>
       <p:sp>
         <p:nvSpPr>
-          <p:cNvPr id="8" name="Text 6"/>
-          <p:cNvSpPr/>
-          <p:nvPr/>
-        </p:nvSpPr>
-        <p:spPr>
-          <a:xfrm>
-            <a:off x="731520" y="1656893"/>
+          <p:cNvPr id="9" name="Text 7"/>
+          <p:cNvSpPr/>
+          <p:nvPr/>
+        </p:nvSpPr>
+        <p:spPr>
+          <a:xfrm>
+            <a:off x="731520" y="1976933"/>
             <a:ext cx="1371600" cy="329184"/>
           </a:xfrm>
           <a:prstGeom prst="rect">
@@ -2993,14 +3121,14 @@
       </p:sp>
       <p:sp>
         <p:nvSpPr>
-          <p:cNvPr id="9" name="Text 7"/>
-          <p:cNvSpPr/>
-          <p:nvPr/>
-        </p:nvSpPr>
-        <p:spPr>
-          <a:xfrm>
-            <a:off x="731520" y="2148840"/>
-            <a:ext cx="3218688" cy="3474720"/>
+          <p:cNvPr id="10" name="Text 8"/>
+          <p:cNvSpPr/>
+          <p:nvPr/>
+        </p:nvSpPr>
+        <p:spPr>
+          <a:xfrm>
+            <a:off x="731520" y="2468880"/>
+            <a:ext cx="3218688" cy="3154680"/>
           </a:xfrm>
           <a:prstGeom prst="rect">
             <a:avLst/>
@@ -3055,14 +3183,14 @@
       </p:sp>
       <p:sp>
         <p:nvSpPr>
-          <p:cNvPr id="10" name="Shape 8"/>
-          <p:cNvSpPr/>
-          <p:nvPr/>
-        </p:nvSpPr>
-        <p:spPr>
-          <a:xfrm>
-            <a:off x="4343400" y="1463040"/>
-            <a:ext cx="3675888" cy="4343400"/>
+          <p:cNvPr id="11" name="Shape 9"/>
+          <p:cNvSpPr/>
+          <p:nvPr/>
+        </p:nvSpPr>
+        <p:spPr>
+          <a:xfrm>
+            <a:off x="4343400" y="1783080"/>
+            <a:ext cx="3675888" cy="4023360"/>
           </a:xfrm>
           <a:prstGeom prst="roundRect">
             <a:avLst>
@@ -3082,13 +3210,13 @@
       </p:sp>
       <p:sp>
         <p:nvSpPr>
-          <p:cNvPr id="11" name="Shape 9"/>
-          <p:cNvSpPr/>
-          <p:nvPr/>
-        </p:nvSpPr>
-        <p:spPr>
-          <a:xfrm>
-            <a:off x="4572000" y="1664208"/>
+          <p:cNvPr id="12" name="Shape 10"/>
+          <p:cNvSpPr/>
+          <p:nvPr/>
+        </p:nvSpPr>
+        <p:spPr>
+          <a:xfrm>
+            <a:off x="4572000" y="1984248"/>
             <a:ext cx="1371600" cy="310896"/>
           </a:xfrm>
           <a:prstGeom prst="roundRect">
@@ -3104,13 +3232,13 @@
       </p:sp>
       <p:sp>
         <p:nvSpPr>
-          <p:cNvPr id="12" name="Text 10"/>
-          <p:cNvSpPr/>
-          <p:nvPr/>
-        </p:nvSpPr>
-        <p:spPr>
-          <a:xfrm>
-            <a:off x="4572000" y="1656893"/>
+          <p:cNvPr id="13" name="Text 11"/>
+          <p:cNvSpPr/>
+          <p:nvPr/>
+        </p:nvSpPr>
+        <p:spPr>
+          <a:xfrm>
+            <a:off x="4572000" y="1976933"/>
             <a:ext cx="1371600" cy="329184"/>
           </a:xfrm>
           <a:prstGeom prst="rect">
@@ -3143,14 +3271,14 @@
       </p:sp>
       <p:sp>
         <p:nvSpPr>
-          <p:cNvPr id="13" name="Text 11"/>
-          <p:cNvSpPr/>
-          <p:nvPr/>
-        </p:nvSpPr>
-        <p:spPr>
-          <a:xfrm>
-            <a:off x="4572000" y="2148840"/>
-            <a:ext cx="3218688" cy="3474720"/>
+          <p:cNvPr id="14" name="Text 12"/>
+          <p:cNvSpPr/>
+          <p:nvPr/>
+        </p:nvSpPr>
+        <p:spPr>
+          <a:xfrm>
+            <a:off x="4572000" y="2468880"/>
+            <a:ext cx="3218688" cy="3154680"/>
           </a:xfrm>
           <a:prstGeom prst="rect">
             <a:avLst/>
@@ -3225,14 +3353,14 @@
       </p:sp>
       <p:sp>
         <p:nvSpPr>
-          <p:cNvPr id="14" name="Shape 12"/>
-          <p:cNvSpPr/>
-          <p:nvPr/>
-        </p:nvSpPr>
-        <p:spPr>
-          <a:xfrm>
-            <a:off x="8183880" y="1463040"/>
-            <a:ext cx="3675888" cy="4343400"/>
+          <p:cNvPr id="15" name="Shape 13"/>
+          <p:cNvSpPr/>
+          <p:nvPr/>
+        </p:nvSpPr>
+        <p:spPr>
+          <a:xfrm>
+            <a:off x="8183880" y="1783080"/>
+            <a:ext cx="3675888" cy="4023360"/>
           </a:xfrm>
           <a:prstGeom prst="roundRect">
             <a:avLst>
@@ -3252,13 +3380,13 @@
       </p:sp>
       <p:sp>
         <p:nvSpPr>
-          <p:cNvPr id="15" name="Shape 13"/>
-          <p:cNvSpPr/>
-          <p:nvPr/>
-        </p:nvSpPr>
-        <p:spPr>
-          <a:xfrm>
-            <a:off x="8412480" y="1664208"/>
+          <p:cNvPr id="16" name="Shape 14"/>
+          <p:cNvSpPr/>
+          <p:nvPr/>
+        </p:nvSpPr>
+        <p:spPr>
+          <a:xfrm>
+            <a:off x="8412480" y="1984248"/>
             <a:ext cx="1371600" cy="310896"/>
           </a:xfrm>
           <a:prstGeom prst="roundRect">
@@ -3274,13 +3402,13 @@
       </p:sp>
       <p:sp>
         <p:nvSpPr>
-          <p:cNvPr id="16" name="Text 14"/>
-          <p:cNvSpPr/>
-          <p:nvPr/>
-        </p:nvSpPr>
-        <p:spPr>
-          <a:xfrm>
-            <a:off x="8412480" y="1656893"/>
+          <p:cNvPr id="17" name="Text 15"/>
+          <p:cNvSpPr/>
+          <p:nvPr/>
+        </p:nvSpPr>
+        <p:spPr>
+          <a:xfrm>
+            <a:off x="8412480" y="1976933"/>
             <a:ext cx="1371600" cy="329184"/>
           </a:xfrm>
           <a:prstGeom prst="rect">
@@ -3313,14 +3441,14 @@
       </p:sp>
       <p:sp>
         <p:nvSpPr>
-          <p:cNvPr id="17" name="Text 15"/>
-          <p:cNvSpPr/>
-          <p:nvPr/>
-        </p:nvSpPr>
-        <p:spPr>
-          <a:xfrm>
-            <a:off x="8412480" y="2148840"/>
-            <a:ext cx="3218688" cy="3474720"/>
+          <p:cNvPr id="18" name="Text 16"/>
+          <p:cNvSpPr/>
+          <p:nvPr/>
+        </p:nvSpPr>
+        <p:spPr>
+          <a:xfrm>
+            <a:off x="8412480" y="2468880"/>
+            <a:ext cx="3218688" cy="3154680"/>
           </a:xfrm>
           <a:prstGeom prst="rect">
             <a:avLst/>
@@ -5112,13 +5240,13 @@
             <a:r>
               <a:rPr lang="en-US" sz="1200" b="1" spc="300" kern="0" dirty="0">
                 <a:solidFill>
-                  <a:srgbClr val="3FCF6E"/>
-                </a:solidFill>
-                <a:latin typeface="Calibri" pitchFamily="34" charset="0"/>
-                <a:ea typeface="Calibri" pitchFamily="34" charset="-122"/>
-                <a:cs typeface="Calibri" pitchFamily="34" charset="-120"/>
-              </a:rPr>
-              <a:t>10 / LA PROPOSITION</a:t>
+                  <a:srgbClr val="F0B429"/>
+                </a:solidFill>
+                <a:latin typeface="Calibri" pitchFamily="34" charset="0"/>
+                <a:ea typeface="Calibri" pitchFamily="34" charset="-122"/>
+                <a:cs typeface="Calibri" pitchFamily="34" charset="-120"/>
+              </a:rPr>
+              <a:t>10 / LA PROCHAINE HISTOIRE</a:t>
             </a:r>
             <a:endParaRPr lang="en-US" sz="1200" dirty="0"/>
           </a:p>
@@ -5133,7 +5261,7 @@
         <p:spPr>
           <a:xfrm>
             <a:off x="502920" y="676656"/>
-            <a:ext cx="11155680" cy="685800"/>
+            <a:ext cx="10972800" cy="685800"/>
           </a:xfrm>
           <a:prstGeom prst="rect">
             <a:avLst/>
@@ -5157,7 +5285,7 @@
                 <a:ea typeface="Calibri" pitchFamily="34" charset="-122"/>
                 <a:cs typeface="Calibri" pitchFamily="34" charset="-120"/>
               </a:rPr>
-              <a:t>Un stage : la promesse devient un rythme</a:t>
+              <a:t>Le drone : reconstruire les sites en 3D</a:t>
             </a:r>
             <a:endParaRPr lang="en-US" sz="3000" dirty="0"/>
           </a:p>
@@ -5196,7 +5324,7 @@
                 <a:ea typeface="Calibri" pitchFamily="34" charset="-122"/>
                 <a:cs typeface="Calibri" pitchFamily="34" charset="-120"/>
               </a:rPr>
-              <a:t>Deux semaines ont suffi une fois. Un cadre de stage en fait une cadence : un changement mesurable toutes les deux semaines, pendant trois mois.</a:t>
+              <a:t>Une étude de site aujourd'hui : une visite, des photos, un mètre — et la cote qui manque se découvre au bureau, à 80 km du site.</a:t>
             </a:r>
             <a:endParaRPr lang="en-US" sz="1350" dirty="0"/>
           </a:p>
@@ -5210,12 +5338,12 @@
         </p:nvSpPr>
         <p:spPr>
           <a:xfrm>
-            <a:off x="502920" y="2011680"/>
-            <a:ext cx="3675888" cy="3063240"/>
+            <a:off x="502920" y="1783080"/>
+            <a:ext cx="3675888" cy="3977640"/>
           </a:xfrm>
           <a:prstGeom prst="roundRect">
             <a:avLst>
-              <a:gd name="adj" fmla="val 2687"/>
+              <a:gd name="adj" fmla="val 2239"/>
             </a:avLst>
           </a:prstGeom>
           <a:solidFill>
@@ -5237,8 +5365,8 @@
         </p:nvSpPr>
         <p:spPr>
           <a:xfrm>
-            <a:off x="731520" y="2240280"/>
-            <a:ext cx="1188720" cy="310896"/>
+            <a:off x="731520" y="1984248"/>
+            <a:ext cx="1463040" cy="310896"/>
           </a:xfrm>
           <a:prstGeom prst="roundRect">
             <a:avLst>
@@ -5246,7 +5374,7 @@
             </a:avLst>
           </a:prstGeom>
           <a:solidFill>
-            <a:srgbClr val="58A6FF"/>
+            <a:srgbClr val="F85149"/>
           </a:solidFill>
           <a:ln/>
         </p:spPr>
@@ -5259,8 +5387,8 @@
         </p:nvSpPr>
         <p:spPr>
           <a:xfrm>
-            <a:off x="731520" y="2232965"/>
-            <a:ext cx="1188720" cy="329184"/>
+            <a:off x="731520" y="1976933"/>
+            <a:ext cx="1463040" cy="329184"/>
           </a:xfrm>
           <a:prstGeom prst="rect">
             <a:avLst/>
@@ -5276,7 +5404,7 @@
               <a:buNone/>
             </a:pPr>
             <a:r>
-              <a:rPr lang="en-US" sz="1150" b="1" dirty="0">
+              <a:rPr lang="en-US" sz="1050" b="1" dirty="0">
                 <a:solidFill>
                   <a:srgbClr val="0B1626"/>
                 </a:solidFill>
@@ -5284,55 +5412,61 @@
                 <a:ea typeface="Calibri" pitchFamily="34" charset="-122"/>
                 <a:cs typeface="Calibri" pitchFamily="34" charset="-120"/>
               </a:rPr>
-              <a:t>MOIS 1</a:t>
+              <a:t>PROBLÈME</a:t>
+            </a:r>
+            <a:endParaRPr lang="en-US" sz="1050" dirty="0"/>
+          </a:p>
+        </p:txBody>
+      </p:sp>
+      <p:sp>
+        <p:nvSpPr>
+          <p:cNvPr id="10" name="Text 8"/>
+          <p:cNvSpPr/>
+          <p:nvPr/>
+        </p:nvSpPr>
+        <p:spPr>
+          <a:xfrm>
+            <a:off x="731520" y="2468880"/>
+            <a:ext cx="3218688" cy="3154680"/>
+          </a:xfrm>
+          <a:prstGeom prst="rect">
+            <a:avLst/>
+          </a:prstGeom>
+          <a:noFill/>
+          <a:ln/>
+        </p:spPr>
+        <p:txBody>
+          <a:bodyPr wrap="square" lIns="0" tIns="0" rIns="0" bIns="0" rtlCol="0" anchor="t"/>
+          <a:lstStyle/>
+          <a:p>
+            <a:pPr indent="0" marL="0">
+              <a:spcAft>
+                <a:spcPts val="800"/>
+              </a:spcAft>
+              <a:buNone/>
+            </a:pPr>
+            <a:r>
+              <a:rPr lang="en-US" sz="1150" dirty="0">
+                <a:solidFill>
+                  <a:srgbClr val="EAF2FB"/>
+                </a:solidFill>
+                <a:latin typeface="Calibri" pitchFamily="34" charset="0"/>
+                <a:ea typeface="Calibri" pitchFamily="34" charset="-122"/>
+                <a:cs typeface="Calibri" pitchFamily="34" charset="-120"/>
+              </a:rPr>
+              <a:t>Une étude de site ne vit qu'une fois : ce qui n'a pas été mesuré ce jour-là est perdu.</a:t>
             </a:r>
             <a:endParaRPr lang="en-US" sz="1150" dirty="0"/>
           </a:p>
-        </p:txBody>
-      </p:sp>
-      <p:sp>
-        <p:nvSpPr>
-          <p:cNvPr id="10" name="Text 8"/>
-          <p:cNvSpPr/>
-          <p:nvPr/>
-        </p:nvSpPr>
-        <p:spPr>
-          <a:xfrm>
-            <a:off x="731520" y="2724912"/>
-            <a:ext cx="3246120" cy="2240280"/>
-          </a:xfrm>
-          <a:prstGeom prst="rect">
-            <a:avLst/>
-          </a:prstGeom>
-          <a:noFill/>
-          <a:ln/>
-        </p:spPr>
-        <p:txBody>
-          <a:bodyPr wrap="square" lIns="0" tIns="0" rIns="0" bIns="0" rtlCol="0" anchor="t"/>
-          <a:lstStyle/>
-          <a:p>
-            <a:pPr indent="0" marL="0">
-              <a:buNone/>
-            </a:pPr>
-            <a:r>
-              <a:rPr lang="en-US" sz="1080" b="1" dirty="0">
-                <a:solidFill>
-                  <a:srgbClr val="58A6FF"/>
-                </a:solidFill>
-                <a:latin typeface="Calibri" pitchFamily="34" charset="0"/>
-                <a:ea typeface="Calibri" pitchFamily="34" charset="-122"/>
-                <a:cs typeface="Calibri" pitchFamily="34" charset="-120"/>
-              </a:rPr>
-              <a:t>Semaines 1-2 — </a:t>
-            </a:r>
+          <a:p>
             <a:pPr indent="0" marL="0">
               <a:spcAft>
-                <a:spcPts val="900"/>
+                <a:spcPts val="800"/>
               </a:spcAft>
               <a:buNone/>
             </a:pPr>
             <a:r>
-              <a:rPr lang="en-US" sz="1080" dirty="0">
+              <a:rPr lang="en-US" sz="1150" dirty="0">
                 <a:solidFill>
                   <a:srgbClr val="EAF2FB"/>
                 </a:solidFill>
@@ -5340,33 +5474,19 @@
                 <a:ea typeface="Calibri" pitchFamily="34" charset="-122"/>
                 <a:cs typeface="Calibri" pitchFamily="34" charset="-120"/>
               </a:rPr>
-              <a:t>Stock UC v2 : import des listes attendues (CSV) — un manquant se voit AVANT la fin du chantier, plus jamais après.</a:t>
-            </a:r>
-            <a:endParaRPr lang="en-US" sz="1080" dirty="0"/>
-          </a:p>
-          <a:p>
-            <a:pPr indent="0" marL="0">
-              <a:buNone/>
-            </a:pPr>
-            <a:r>
-              <a:rPr lang="en-US" sz="1080" b="1" dirty="0">
-                <a:solidFill>
-                  <a:srgbClr val="58A6FF"/>
-                </a:solidFill>
-                <a:latin typeface="Calibri" pitchFamily="34" charset="0"/>
-                <a:ea typeface="Calibri" pitchFamily="34" charset="-122"/>
-                <a:cs typeface="Calibri" pitchFamily="34" charset="-120"/>
-              </a:rPr>
-              <a:t>Semaines 3-4 — </a:t>
-            </a:r>
+              <a:t>Les photos plates ne répondent pas aux questions de demain — et chaque cote oubliée coûte un aller-retour.</a:t>
+            </a:r>
+            <a:endParaRPr lang="en-US" sz="1150" dirty="0"/>
+          </a:p>
+          <a:p>
             <a:pPr indent="0" marL="0">
               <a:spcAft>
-                <a:spcPts val="900"/>
+                <a:spcPts val="800"/>
               </a:spcAft>
               <a:buNone/>
             </a:pPr>
             <a:r>
-              <a:rPr lang="en-US" sz="1080" dirty="0">
+              <a:rPr lang="en-US" sz="1150" dirty="0">
                 <a:solidFill>
                   <a:srgbClr val="EAF2FB"/>
                 </a:solidFill>
@@ -5374,9 +5494,9 @@
                 <a:ea typeface="Calibri" pitchFamily="34" charset="-122"/>
                 <a:cs typeface="Calibri" pitchFamily="34" charset="-120"/>
               </a:rPr>
-              <a:t>le pilote Hanover de référence : fusionner notre table de commandes avec Hanover_Diag, avec son auteur.</a:t>
-            </a:r>
-            <a:endParaRPr lang="en-US" sz="1080" dirty="0"/>
+              <a:t>Les implantations se décident sur des plans parfois anciens, parfois faux.</a:t>
+            </a:r>
+            <a:endParaRPr lang="en-US" sz="1150" dirty="0"/>
           </a:p>
         </p:txBody>
       </p:sp>
@@ -5388,12 +5508,12 @@
         </p:nvSpPr>
         <p:spPr>
           <a:xfrm>
-            <a:off x="4343400" y="2011680"/>
-            <a:ext cx="3675888" cy="3063240"/>
+            <a:off x="4343400" y="1783080"/>
+            <a:ext cx="3675888" cy="3977640"/>
           </a:xfrm>
           <a:prstGeom prst="roundRect">
             <a:avLst>
-              <a:gd name="adj" fmla="val 2687"/>
+              <a:gd name="adj" fmla="val 2239"/>
             </a:avLst>
           </a:prstGeom>
           <a:solidFill>
@@ -5415,8 +5535,8 @@
         </p:nvSpPr>
         <p:spPr>
           <a:xfrm>
-            <a:off x="4572000" y="2240280"/>
-            <a:ext cx="1188720" cy="310896"/>
+            <a:off x="4572000" y="1984248"/>
+            <a:ext cx="1463040" cy="310896"/>
           </a:xfrm>
           <a:prstGeom prst="roundRect">
             <a:avLst>
@@ -5424,7 +5544,7 @@
             </a:avLst>
           </a:prstGeom>
           <a:solidFill>
-            <a:srgbClr val="BC8CFF"/>
+            <a:srgbClr val="F0B429"/>
           </a:solidFill>
           <a:ln/>
         </p:spPr>
@@ -5437,8 +5557,8 @@
         </p:nvSpPr>
         <p:spPr>
           <a:xfrm>
-            <a:off x="4572000" y="2232965"/>
-            <a:ext cx="1188720" cy="329184"/>
+            <a:off x="4572000" y="1976933"/>
+            <a:ext cx="1463040" cy="329184"/>
           </a:xfrm>
           <a:prstGeom prst="rect">
             <a:avLst/>
@@ -5454,7 +5574,7 @@
               <a:buNone/>
             </a:pPr>
             <a:r>
-              <a:rPr lang="en-US" sz="1150" b="1" dirty="0">
+              <a:rPr lang="en-US" sz="1050" b="1" dirty="0">
                 <a:solidFill>
                   <a:srgbClr val="0B1626"/>
                 </a:solidFill>
@@ -5462,55 +5582,61 @@
                 <a:ea typeface="Calibri" pitchFamily="34" charset="-122"/>
                 <a:cs typeface="Calibri" pitchFamily="34" charset="-120"/>
               </a:rPr>
-              <a:t>MOIS 2</a:t>
+              <a:t>PROPOSITION</a:t>
+            </a:r>
+            <a:endParaRPr lang="en-US" sz="1050" dirty="0"/>
+          </a:p>
+        </p:txBody>
+      </p:sp>
+      <p:sp>
+        <p:nvSpPr>
+          <p:cNvPr id="14" name="Text 12"/>
+          <p:cNvSpPr/>
+          <p:nvPr/>
+        </p:nvSpPr>
+        <p:spPr>
+          <a:xfrm>
+            <a:off x="4572000" y="2468880"/>
+            <a:ext cx="3218688" cy="3154680"/>
+          </a:xfrm>
+          <a:prstGeom prst="rect">
+            <a:avLst/>
+          </a:prstGeom>
+          <a:noFill/>
+          <a:ln/>
+        </p:spPr>
+        <p:txBody>
+          <a:bodyPr wrap="square" lIns="0" tIns="0" rIns="0" bIns="0" rtlCol="0" anchor="t"/>
+          <a:lstStyle/>
+          <a:p>
+            <a:pPr indent="0" marL="0">
+              <a:spcAft>
+                <a:spcPts val="800"/>
+              </a:spcAft>
+              <a:buNone/>
+            </a:pPr>
+            <a:r>
+              <a:rPr lang="en-US" sz="1150" dirty="0">
+                <a:solidFill>
+                  <a:srgbClr val="EAF2FB"/>
+                </a:solidFill>
+                <a:latin typeface="Calibri" pitchFamily="34" charset="0"/>
+                <a:ea typeface="Calibri" pitchFamily="34" charset="-122"/>
+                <a:cs typeface="Calibri" pitchFamily="34" charset="-120"/>
+              </a:rPr>
+              <a:t>Un drone photographie le site sous tous les angles ; la photogrammétrie en reconstruit un jumeau 3D — dépôt, station, atelier.</a:t>
             </a:r>
             <a:endParaRPr lang="en-US" sz="1150" dirty="0"/>
           </a:p>
-        </p:txBody>
-      </p:sp>
-      <p:sp>
-        <p:nvSpPr>
-          <p:cNvPr id="14" name="Text 12"/>
-          <p:cNvSpPr/>
-          <p:nvPr/>
-        </p:nvSpPr>
-        <p:spPr>
-          <a:xfrm>
-            <a:off x="4572000" y="2724912"/>
-            <a:ext cx="3246120" cy="2240280"/>
-          </a:xfrm>
-          <a:prstGeom prst="rect">
-            <a:avLst/>
-          </a:prstGeom>
-          <a:noFill/>
-          <a:ln/>
-        </p:spPr>
-        <p:txBody>
-          <a:bodyPr wrap="square" lIns="0" tIns="0" rIns="0" bIns="0" rtlCol="0" anchor="t"/>
-          <a:lstStyle/>
-          <a:p>
-            <a:pPr indent="0" marL="0">
-              <a:buNone/>
-            </a:pPr>
-            <a:r>
-              <a:rPr lang="en-US" sz="1080" b="1" dirty="0">
-                <a:solidFill>
-                  <a:srgbClr val="BC8CFF"/>
-                </a:solidFill>
-                <a:latin typeface="Calibri" pitchFamily="34" charset="0"/>
-                <a:ea typeface="Calibri" pitchFamily="34" charset="-122"/>
-                <a:cs typeface="Calibri" pitchFamily="34" charset="-120"/>
-              </a:rPr>
-              <a:t>Semaines 5-6 — </a:t>
-            </a:r>
+          <a:p>
             <a:pPr indent="0" marL="0">
               <a:spcAft>
-                <a:spcPts val="900"/>
+                <a:spcPts val="800"/>
               </a:spcAft>
               <a:buNone/>
             </a:pPr>
             <a:r>
-              <a:rPr lang="en-US" sz="1080" dirty="0">
+              <a:rPr lang="en-US" sz="1150" dirty="0">
                 <a:solidFill>
                   <a:srgbClr val="EAF2FB"/>
                 </a:solidFill>
@@ -5518,33 +5644,19 @@
                 <a:ea typeface="Calibri" pitchFamily="34" charset="-122"/>
                 <a:cs typeface="Calibri" pitchFamily="34" charset="-120"/>
               </a:rPr>
-              <a:t>/rapport en production sur les contrats d'études en cours ; métrique heures-par-étude, avant / après.</a:t>
-            </a:r>
-            <a:endParaRPr lang="en-US" sz="1080" dirty="0"/>
-          </a:p>
-          <a:p>
-            <a:pPr indent="0" marL="0">
-              <a:buNone/>
-            </a:pPr>
-            <a:r>
-              <a:rPr lang="en-US" sz="1080" b="1" dirty="0">
-                <a:solidFill>
-                  <a:srgbClr val="BC8CFF"/>
-                </a:solidFill>
-                <a:latin typeface="Calibri" pitchFamily="34" charset="0"/>
-                <a:ea typeface="Calibri" pitchFamily="34" charset="-122"/>
-                <a:cs typeface="Calibri" pitchFamily="34" charset="-120"/>
-              </a:rPr>
-              <a:t>Semaines 7-8 — </a:t>
-            </a:r>
+              <a:t>On mesure à volonté, on rejoue la visite, on archive l'état avant / après chantier.</a:t>
+            </a:r>
+            <a:endParaRPr lang="en-US" sz="1150" dirty="0"/>
+          </a:p>
+          <a:p>
             <a:pPr indent="0" marL="0">
               <a:spcAft>
-                <a:spcPts val="900"/>
+                <a:spcPts val="800"/>
               </a:spcAft>
               <a:buNone/>
             </a:pPr>
             <a:r>
-              <a:rPr lang="en-US" sz="1080" dirty="0">
+              <a:rPr lang="en-US" sz="1150" dirty="0">
                 <a:solidFill>
                   <a:srgbClr val="EAF2FB"/>
                 </a:solidFill>
@@ -5552,9 +5664,9 @@
                 <a:ea typeface="Calibri" pitchFamily="34" charset="-122"/>
                 <a:cs typeface="Calibri" pitchFamily="34" charset="-120"/>
               </a:rPr>
-              <a:t>Mobitec hors du mode gabarit : campagne capture-diff contre l'éditeur vendeur.</a:t>
-            </a:r>
-            <a:endParaRPr lang="en-US" sz="1080" dirty="0"/>
+              <a:t>L'atout maison : le moteur 3D des rapports rend déjà des bus entiers — poser le site autour est la suite logique. Et le vol, je connais : contrôleur de vol construit de mes mains (stabilisation PID &lt; 10 ms sur STM32).</a:t>
+            </a:r>
+            <a:endParaRPr lang="en-US" sz="1150" dirty="0"/>
           </a:p>
         </p:txBody>
       </p:sp>
@@ -5566,12 +5678,12 @@
         </p:nvSpPr>
         <p:spPr>
           <a:xfrm>
-            <a:off x="8183880" y="2011680"/>
-            <a:ext cx="3675888" cy="3063240"/>
+            <a:off x="8183880" y="1783080"/>
+            <a:ext cx="3675888" cy="3977640"/>
           </a:xfrm>
           <a:prstGeom prst="roundRect">
             <a:avLst>
-              <a:gd name="adj" fmla="val 2687"/>
+              <a:gd name="adj" fmla="val 2239"/>
             </a:avLst>
           </a:prstGeom>
           <a:solidFill>
@@ -5593,8 +5705,8 @@
         </p:nvSpPr>
         <p:spPr>
           <a:xfrm>
-            <a:off x="8412480" y="2240280"/>
-            <a:ext cx="1188720" cy="310896"/>
+            <a:off x="8412480" y="1984248"/>
+            <a:ext cx="1920240" cy="310896"/>
           </a:xfrm>
           <a:prstGeom prst="roundRect">
             <a:avLst>
@@ -5602,7 +5714,7 @@
             </a:avLst>
           </a:prstGeom>
           <a:solidFill>
-            <a:srgbClr val="3FCF6E"/>
+            <a:srgbClr val="3DDC84"/>
           </a:solidFill>
           <a:ln/>
         </p:spPr>
@@ -5615,8 +5727,8 @@
         </p:nvSpPr>
         <p:spPr>
           <a:xfrm>
-            <a:off x="8412480" y="2232965"/>
-            <a:ext cx="1188720" cy="329184"/>
+            <a:off x="8412480" y="1976933"/>
+            <a:ext cx="1920240" cy="329184"/>
           </a:xfrm>
           <a:prstGeom prst="rect">
             <a:avLst/>
@@ -5632,7 +5744,7 @@
               <a:buNone/>
             </a:pPr>
             <a:r>
-              <a:rPr lang="en-US" sz="1150" b="1" dirty="0">
+              <a:rPr lang="en-US" sz="1050" b="1" dirty="0">
                 <a:solidFill>
                   <a:srgbClr val="0B1626"/>
                 </a:solidFill>
@@ -5640,55 +5752,61 @@
                 <a:ea typeface="Calibri" pitchFamily="34" charset="-122"/>
                 <a:cs typeface="Calibri" pitchFamily="34" charset="-120"/>
               </a:rPr>
-              <a:t>MOIS 3</a:t>
+              <a:t>CE QUE ÇA OUVRE</a:t>
+            </a:r>
+            <a:endParaRPr lang="en-US" sz="1050" dirty="0"/>
+          </a:p>
+        </p:txBody>
+      </p:sp>
+      <p:sp>
+        <p:nvSpPr>
+          <p:cNvPr id="18" name="Text 16"/>
+          <p:cNvSpPr/>
+          <p:nvPr/>
+        </p:nvSpPr>
+        <p:spPr>
+          <a:xfrm>
+            <a:off x="8412480" y="2468880"/>
+            <a:ext cx="3218688" cy="3154680"/>
+          </a:xfrm>
+          <a:prstGeom prst="rect">
+            <a:avLst/>
+          </a:prstGeom>
+          <a:noFill/>
+          <a:ln/>
+        </p:spPr>
+        <p:txBody>
+          <a:bodyPr wrap="square" lIns="0" tIns="0" rIns="0" bIns="0" rtlCol="0" anchor="t"/>
+          <a:lstStyle/>
+          <a:p>
+            <a:pPr indent="0" marL="0">
+              <a:spcAft>
+                <a:spcPts val="800"/>
+              </a:spcAft>
+              <a:buNone/>
+            </a:pPr>
+            <a:r>
+              <a:rPr lang="en-US" sz="1150" dirty="0">
+                <a:solidFill>
+                  <a:srgbClr val="EAF2FB"/>
+                </a:solidFill>
+                <a:latin typeface="Calibri" pitchFamily="34" charset="0"/>
+                <a:ea typeface="Calibri" pitchFamily="34" charset="-122"/>
+                <a:cs typeface="Calibri" pitchFamily="34" charset="-120"/>
+              </a:rPr>
+              <a:t>Des études de site mesurables, rejouables, archivées — la visite qui ne se perd plus jamais.</a:t>
             </a:r>
             <a:endParaRPr lang="en-US" sz="1150" dirty="0"/>
           </a:p>
-        </p:txBody>
-      </p:sp>
-      <p:sp>
-        <p:nvSpPr>
-          <p:cNvPr id="18" name="Text 16"/>
-          <p:cNvSpPr/>
-          <p:nvPr/>
-        </p:nvSpPr>
-        <p:spPr>
-          <a:xfrm>
-            <a:off x="8412480" y="2724912"/>
-            <a:ext cx="3246120" cy="2240280"/>
-          </a:xfrm>
-          <a:prstGeom prst="rect">
-            <a:avLst/>
-          </a:prstGeom>
-          <a:noFill/>
-          <a:ln/>
-        </p:spPr>
-        <p:txBody>
-          <a:bodyPr wrap="square" lIns="0" tIns="0" rIns="0" bIns="0" rtlCol="0" anchor="t"/>
-          <a:lstStyle/>
-          <a:p>
-            <a:pPr indent="0" marL="0">
-              <a:buNone/>
-            </a:pPr>
-            <a:r>
-              <a:rPr lang="en-US" sz="1080" b="1" dirty="0">
-                <a:solidFill>
-                  <a:srgbClr val="3FCF6E"/>
-                </a:solidFill>
-                <a:latin typeface="Calibri" pitchFamily="34" charset="0"/>
-                <a:ea typeface="Calibri" pitchFamily="34" charset="-122"/>
-                <a:cs typeface="Calibri" pitchFamily="34" charset="-120"/>
-              </a:rPr>
-              <a:t>Semaines 9-10 — </a:t>
-            </a:r>
+          <a:p>
             <a:pPr indent="0" marL="0">
               <a:spcAft>
-                <a:spcPts val="900"/>
+                <a:spcPts val="800"/>
               </a:spcAft>
               <a:buNone/>
             </a:pPr>
             <a:r>
-              <a:rPr lang="en-US" sz="1080" dirty="0">
+              <a:rPr lang="en-US" sz="1150" dirty="0">
                 <a:solidFill>
                   <a:srgbClr val="EAF2FB"/>
                 </a:solidFill>
@@ -5696,33 +5814,19 @@
                 <a:ea typeface="Calibri" pitchFamily="34" charset="-122"/>
                 <a:cs typeface="Calibri" pitchFamily="34" charset="-120"/>
               </a:rPr>
-              <a:t>flux &amp; santé rapport branchés dans la routine COPIL — les deux questions que le comité pose vraiment.</a:t>
-            </a:r>
-            <a:endParaRPr lang="en-US" sz="1080" dirty="0"/>
-          </a:p>
-          <a:p>
-            <a:pPr indent="0" marL="0">
-              <a:buNone/>
-            </a:pPr>
-            <a:r>
-              <a:rPr lang="en-US" sz="1080" b="1" dirty="0">
-                <a:solidFill>
-                  <a:srgbClr val="3FCF6E"/>
-                </a:solidFill>
-                <a:latin typeface="Calibri" pitchFamily="34" charset="0"/>
-                <a:ea typeface="Calibri" pitchFamily="34" charset="-122"/>
-                <a:cs typeface="Calibri" pitchFamily="34" charset="-120"/>
-              </a:rPr>
-              <a:t>Semaines 11-12 — </a:t>
-            </a:r>
+              <a:t>Site + véhicule dans la même scène 3D : l'implantation se simule avant de percer le premier trou.</a:t>
+            </a:r>
+            <a:endParaRPr lang="en-US" sz="1150" dirty="0"/>
+          </a:p>
+          <a:p>
             <a:pPr indent="0" marL="0">
               <a:spcAft>
-                <a:spcPts val="900"/>
+                <a:spcPts val="800"/>
               </a:spcAft>
               <a:buNone/>
             </a:pPr>
             <a:r>
-              <a:rPr lang="en-US" sz="1080" dirty="0">
+              <a:rPr lang="en-US" sz="1150" dirty="0">
                 <a:solidFill>
                   <a:srgbClr val="EAF2FB"/>
                 </a:solidFill>
@@ -5730,87 +5834,46 @@
                 <a:ea typeface="Calibri" pitchFamily="34" charset="-122"/>
                 <a:cs typeface="Calibri" pitchFamily="34" charset="-120"/>
               </a:rPr>
-              <a:t>transfert : playbooks à jour, formation courte à l'équipe, bilan chiffré de chaque mission.</a:t>
-            </a:r>
-            <a:endParaRPr lang="en-US" sz="1080" dirty="0"/>
-          </a:p>
-        </p:txBody>
-      </p:sp>
-      <p:sp>
-        <p:nvSpPr>
-          <p:cNvPr id="19" name="Shape 17"/>
-          <p:cNvSpPr/>
-          <p:nvPr/>
-        </p:nvSpPr>
-        <p:spPr>
-          <a:xfrm>
-            <a:off x="502920" y="5257800"/>
-            <a:ext cx="11173968" cy="914400"/>
-          </a:xfrm>
-          <a:prstGeom prst="roundRect">
-            <a:avLst>
-              <a:gd name="adj" fmla="val 9000"/>
-            </a:avLst>
-          </a:prstGeom>
-          <a:solidFill>
-            <a:srgbClr val="1A3350"/>
-          </a:solidFill>
-          <a:ln w="9525">
-            <a:solidFill>
-              <a:srgbClr val="2C4A6B"/>
-            </a:solidFill>
-            <a:prstDash val="solid"/>
-          </a:ln>
-        </p:spPr>
-      </p:sp>
-      <p:sp>
-        <p:nvSpPr>
-          <p:cNvPr id="20" name="Text 18"/>
-          <p:cNvSpPr/>
-          <p:nvPr/>
-        </p:nvSpPr>
-        <p:spPr>
-          <a:xfrm>
-            <a:off x="822960" y="5486400"/>
-            <a:ext cx="10515600" cy="548640"/>
-          </a:xfrm>
-          <a:prstGeom prst="rect">
-            <a:avLst/>
-          </a:prstGeom>
-          <a:noFill/>
-          <a:ln/>
-        </p:spPr>
-        <p:txBody>
-          <a:bodyPr wrap="square" lIns="0" tIns="0" rIns="0" bIns="0" rtlCol="0" anchor="t"/>
-          <a:lstStyle/>
-          <a:p>
-            <a:pPr indent="0" marL="0">
-              <a:buNone/>
-            </a:pPr>
-            <a:r>
-              <a:rPr lang="en-US" sz="1250" b="1" dirty="0">
-                <a:solidFill>
-                  <a:srgbClr val="3FCF6E"/>
-                </a:solidFill>
-                <a:latin typeface="Calibri" pitchFamily="34" charset="0"/>
-                <a:ea typeface="Calibri" pitchFamily="34" charset="-122"/>
-                <a:cs typeface="Calibri" pitchFamily="34" charset="-120"/>
-              </a:rPr>
-              <a:t>Le cadre : </a:t>
-            </a:r>
-            <a:pPr indent="0" marL="0">
-              <a:buNone/>
-            </a:pPr>
-            <a:r>
-              <a:rPr lang="en-US" sz="1250" dirty="0">
-                <a:solidFill>
-                  <a:srgbClr val="EAF2FB"/>
-                </a:solidFill>
-                <a:latin typeface="Calibri" pitchFamily="34" charset="0"/>
-                <a:ea typeface="Calibri" pitchFamily="34" charset="-122"/>
-                <a:cs typeface="Calibri" pitchFamily="34" charset="-120"/>
-              </a:rPr>
-              <a:t>objectifs écrits, point d'étape toutes les deux semaines, livrables mesurés — et le suivi de progression documente déjà tout en Problème → Action → Apprentissage, preuves à l'appui.</a:t>
+              <a:t>Un livrable client spectaculaire — et moins de kilomètres pour plus de réponses.</a:t>
+            </a:r>
+            <a:endParaRPr lang="en-US" sz="1150" dirty="0"/>
+          </a:p>
+        </p:txBody>
+      </p:sp>
+      <p:sp>
+        <p:nvSpPr>
+          <p:cNvPr id="19" name="Text 17"/>
+          <p:cNvSpPr/>
+          <p:nvPr/>
+        </p:nvSpPr>
+        <p:spPr>
+          <a:xfrm>
+            <a:off x="502920" y="5897880"/>
+            <a:ext cx="11173968" cy="365760"/>
+          </a:xfrm>
+          <a:prstGeom prst="rect">
+            <a:avLst/>
+          </a:prstGeom>
+          <a:noFill/>
+          <a:ln/>
+        </p:spPr>
+        <p:txBody>
+          <a:bodyPr wrap="square" lIns="0" tIns="0" rIns="0" bIns="0" rtlCol="0" anchor="ctr"/>
+          <a:lstStyle/>
+          <a:p>
+            <a:pPr algn="ctr" indent="0" marL="0">
+              <a:buNone/>
+            </a:pPr>
+            <a:r>
+              <a:rPr lang="en-US" sz="1250" b="1" i="1" dirty="0">
+                <a:solidFill>
+                  <a:srgbClr val="F0B429"/>
+                </a:solidFill>
+                <a:latin typeface="Calibri" pitchFamily="34" charset="0"/>
+                <a:ea typeface="Calibri" pitchFamily="34" charset="-122"/>
+                <a:cs typeface="Calibri" pitchFamily="34" charset="-120"/>
+              </a:rPr>
+              <a:t>la même logique que Stock UC : capturer une fois, correctement — et ne plus jamais perdre l'information</a:t>
             </a:r>
             <a:endParaRPr lang="en-US" sz="1250" dirty="0"/>
           </a:p>
@@ -5934,6 +5997,881 @@
         </p:nvSpPr>
         <p:spPr>
           <a:xfrm>
+            <a:off x="502920" y="384048"/>
+            <a:ext cx="8229600" cy="292608"/>
+          </a:xfrm>
+          <a:prstGeom prst="rect">
+            <a:avLst/>
+          </a:prstGeom>
+          <a:noFill/>
+          <a:ln/>
+        </p:spPr>
+        <p:txBody>
+          <a:bodyPr wrap="square" lIns="0" tIns="0" rIns="0" bIns="0" rtlCol="0" anchor="ctr"/>
+          <a:lstStyle/>
+          <a:p>
+            <a:pPr indent="0" marL="0">
+              <a:buNone/>
+            </a:pPr>
+            <a:r>
+              <a:rPr lang="en-US" sz="1200" b="1" spc="300" kern="0" dirty="0">
+                <a:solidFill>
+                  <a:srgbClr val="3FCF6E"/>
+                </a:solidFill>
+                <a:latin typeface="Calibri" pitchFamily="34" charset="0"/>
+                <a:ea typeface="Calibri" pitchFamily="34" charset="-122"/>
+                <a:cs typeface="Calibri" pitchFamily="34" charset="-120"/>
+              </a:rPr>
+              <a:t>11 / LA PROPOSITION</a:t>
+            </a:r>
+            <a:endParaRPr lang="en-US" sz="1200" dirty="0"/>
+          </a:p>
+        </p:txBody>
+      </p:sp>
+      <p:sp>
+        <p:nvSpPr>
+          <p:cNvPr id="5" name="Text 3"/>
+          <p:cNvSpPr/>
+          <p:nvPr/>
+        </p:nvSpPr>
+        <p:spPr>
+          <a:xfrm>
+            <a:off x="502920" y="676656"/>
+            <a:ext cx="11155680" cy="685800"/>
+          </a:xfrm>
+          <a:prstGeom prst="rect">
+            <a:avLst/>
+          </a:prstGeom>
+          <a:noFill/>
+          <a:ln/>
+        </p:spPr>
+        <p:txBody>
+          <a:bodyPr wrap="square" lIns="0" tIns="0" rIns="0" bIns="0" rtlCol="0" anchor="ctr"/>
+          <a:lstStyle/>
+          <a:p>
+            <a:pPr indent="0" marL="0">
+              <a:buNone/>
+            </a:pPr>
+            <a:r>
+              <a:rPr lang="en-US" sz="3000" b="1" dirty="0">
+                <a:solidFill>
+                  <a:srgbClr val="EAF2FB"/>
+                </a:solidFill>
+                <a:latin typeface="Calibri" pitchFamily="34" charset="0"/>
+                <a:ea typeface="Calibri" pitchFamily="34" charset="-122"/>
+                <a:cs typeface="Calibri" pitchFamily="34" charset="-120"/>
+              </a:rPr>
+              <a:t>Un stage : la promesse devient un rythme</a:t>
+            </a:r>
+            <a:endParaRPr lang="en-US" sz="3000" dirty="0"/>
+          </a:p>
+        </p:txBody>
+      </p:sp>
+      <p:sp>
+        <p:nvSpPr>
+          <p:cNvPr id="6" name="Text 4"/>
+          <p:cNvSpPr/>
+          <p:nvPr/>
+        </p:nvSpPr>
+        <p:spPr>
+          <a:xfrm>
+            <a:off x="502920" y="1298448"/>
+            <a:ext cx="11155680" cy="457200"/>
+          </a:xfrm>
+          <a:prstGeom prst="rect">
+            <a:avLst/>
+          </a:prstGeom>
+          <a:noFill/>
+          <a:ln/>
+        </p:spPr>
+        <p:txBody>
+          <a:bodyPr wrap="square" lIns="0" tIns="0" rIns="0" bIns="0" rtlCol="0" anchor="ctr"/>
+          <a:lstStyle/>
+          <a:p>
+            <a:pPr indent="0" marL="0">
+              <a:buNone/>
+            </a:pPr>
+            <a:r>
+              <a:rPr lang="en-US" sz="1350" dirty="0">
+                <a:solidFill>
+                  <a:srgbClr val="9DB2C7"/>
+                </a:solidFill>
+                <a:latin typeface="Calibri" pitchFamily="34" charset="0"/>
+                <a:ea typeface="Calibri" pitchFamily="34" charset="-122"/>
+                <a:cs typeface="Calibri" pitchFamily="34" charset="-120"/>
+              </a:rPr>
+              <a:t>Deux semaines ont suffi une fois. Un cadre de stage en fait une cadence : un changement mesurable toutes les deux semaines, pendant trois mois.</a:t>
+            </a:r>
+            <a:endParaRPr lang="en-US" sz="1350" dirty="0"/>
+          </a:p>
+        </p:txBody>
+      </p:sp>
+      <p:sp>
+        <p:nvSpPr>
+          <p:cNvPr id="7" name="Shape 5"/>
+          <p:cNvSpPr/>
+          <p:nvPr/>
+        </p:nvSpPr>
+        <p:spPr>
+          <a:xfrm>
+            <a:off x="502920" y="2011680"/>
+            <a:ext cx="3675888" cy="3063240"/>
+          </a:xfrm>
+          <a:prstGeom prst="roundRect">
+            <a:avLst>
+              <a:gd name="adj" fmla="val 2687"/>
+            </a:avLst>
+          </a:prstGeom>
+          <a:solidFill>
+            <a:srgbClr val="13273D"/>
+          </a:solidFill>
+          <a:ln w="9525">
+            <a:solidFill>
+              <a:srgbClr val="2C4A6B"/>
+            </a:solidFill>
+            <a:prstDash val="solid"/>
+          </a:ln>
+        </p:spPr>
+      </p:sp>
+      <p:sp>
+        <p:nvSpPr>
+          <p:cNvPr id="8" name="Shape 6"/>
+          <p:cNvSpPr/>
+          <p:nvPr/>
+        </p:nvSpPr>
+        <p:spPr>
+          <a:xfrm>
+            <a:off x="731520" y="2240280"/>
+            <a:ext cx="1188720" cy="310896"/>
+          </a:xfrm>
+          <a:prstGeom prst="roundRect">
+            <a:avLst>
+              <a:gd name="adj" fmla="val 50000"/>
+            </a:avLst>
+          </a:prstGeom>
+          <a:solidFill>
+            <a:srgbClr val="58A6FF"/>
+          </a:solidFill>
+          <a:ln/>
+        </p:spPr>
+      </p:sp>
+      <p:sp>
+        <p:nvSpPr>
+          <p:cNvPr id="9" name="Text 7"/>
+          <p:cNvSpPr/>
+          <p:nvPr/>
+        </p:nvSpPr>
+        <p:spPr>
+          <a:xfrm>
+            <a:off x="731520" y="2232965"/>
+            <a:ext cx="1188720" cy="329184"/>
+          </a:xfrm>
+          <a:prstGeom prst="rect">
+            <a:avLst/>
+          </a:prstGeom>
+          <a:noFill/>
+          <a:ln/>
+        </p:spPr>
+        <p:txBody>
+          <a:bodyPr wrap="square" lIns="0" tIns="0" rIns="0" bIns="0" rtlCol="0" anchor="ctr"/>
+          <a:lstStyle/>
+          <a:p>
+            <a:pPr algn="ctr" indent="0" marL="0">
+              <a:buNone/>
+            </a:pPr>
+            <a:r>
+              <a:rPr lang="en-US" sz="1150" b="1" dirty="0">
+                <a:solidFill>
+                  <a:srgbClr val="0B1626"/>
+                </a:solidFill>
+                <a:latin typeface="Calibri" pitchFamily="34" charset="0"/>
+                <a:ea typeface="Calibri" pitchFamily="34" charset="-122"/>
+                <a:cs typeface="Calibri" pitchFamily="34" charset="-120"/>
+              </a:rPr>
+              <a:t>MOIS 1</a:t>
+            </a:r>
+            <a:endParaRPr lang="en-US" sz="1150" dirty="0"/>
+          </a:p>
+        </p:txBody>
+      </p:sp>
+      <p:sp>
+        <p:nvSpPr>
+          <p:cNvPr id="10" name="Text 8"/>
+          <p:cNvSpPr/>
+          <p:nvPr/>
+        </p:nvSpPr>
+        <p:spPr>
+          <a:xfrm>
+            <a:off x="731520" y="2724912"/>
+            <a:ext cx="3246120" cy="2240280"/>
+          </a:xfrm>
+          <a:prstGeom prst="rect">
+            <a:avLst/>
+          </a:prstGeom>
+          <a:noFill/>
+          <a:ln/>
+        </p:spPr>
+        <p:txBody>
+          <a:bodyPr wrap="square" lIns="0" tIns="0" rIns="0" bIns="0" rtlCol="0" anchor="t"/>
+          <a:lstStyle/>
+          <a:p>
+            <a:pPr indent="0" marL="0">
+              <a:buNone/>
+            </a:pPr>
+            <a:r>
+              <a:rPr lang="en-US" sz="1080" b="1" dirty="0">
+                <a:solidFill>
+                  <a:srgbClr val="58A6FF"/>
+                </a:solidFill>
+                <a:latin typeface="Calibri" pitchFamily="34" charset="0"/>
+                <a:ea typeface="Calibri" pitchFamily="34" charset="-122"/>
+                <a:cs typeface="Calibri" pitchFamily="34" charset="-120"/>
+              </a:rPr>
+              <a:t>Semaines 1-2 — </a:t>
+            </a:r>
+            <a:pPr indent="0" marL="0">
+              <a:spcAft>
+                <a:spcPts val="900"/>
+              </a:spcAft>
+              <a:buNone/>
+            </a:pPr>
+            <a:r>
+              <a:rPr lang="en-US" sz="1080" dirty="0">
+                <a:solidFill>
+                  <a:srgbClr val="EAF2FB"/>
+                </a:solidFill>
+                <a:latin typeface="Calibri" pitchFamily="34" charset="0"/>
+                <a:ea typeface="Calibri" pitchFamily="34" charset="-122"/>
+                <a:cs typeface="Calibri" pitchFamily="34" charset="-120"/>
+              </a:rPr>
+              <a:t>Stock UC v2 : import des listes attendues (CSV) — un manquant se voit AVANT la fin du chantier, plus jamais après.</a:t>
+            </a:r>
+            <a:endParaRPr lang="en-US" sz="1080" dirty="0"/>
+          </a:p>
+          <a:p>
+            <a:pPr indent="0" marL="0">
+              <a:buNone/>
+            </a:pPr>
+            <a:r>
+              <a:rPr lang="en-US" sz="1080" b="1" dirty="0">
+                <a:solidFill>
+                  <a:srgbClr val="58A6FF"/>
+                </a:solidFill>
+                <a:latin typeface="Calibri" pitchFamily="34" charset="0"/>
+                <a:ea typeface="Calibri" pitchFamily="34" charset="-122"/>
+                <a:cs typeface="Calibri" pitchFamily="34" charset="-120"/>
+              </a:rPr>
+              <a:t>Semaines 3-4 — </a:t>
+            </a:r>
+            <a:pPr indent="0" marL="0">
+              <a:spcAft>
+                <a:spcPts val="900"/>
+              </a:spcAft>
+              <a:buNone/>
+            </a:pPr>
+            <a:r>
+              <a:rPr lang="en-US" sz="1080" dirty="0">
+                <a:solidFill>
+                  <a:srgbClr val="EAF2FB"/>
+                </a:solidFill>
+                <a:latin typeface="Calibri" pitchFamily="34" charset="0"/>
+                <a:ea typeface="Calibri" pitchFamily="34" charset="-122"/>
+                <a:cs typeface="Calibri" pitchFamily="34" charset="-120"/>
+              </a:rPr>
+              <a:t>le pilote Hanover de référence : fusionner notre table de commandes avec Hanover_Diag, avec son auteur.</a:t>
+            </a:r>
+            <a:endParaRPr lang="en-US" sz="1080" dirty="0"/>
+          </a:p>
+        </p:txBody>
+      </p:sp>
+      <p:sp>
+        <p:nvSpPr>
+          <p:cNvPr id="11" name="Shape 9"/>
+          <p:cNvSpPr/>
+          <p:nvPr/>
+        </p:nvSpPr>
+        <p:spPr>
+          <a:xfrm>
+            <a:off x="4343400" y="2011680"/>
+            <a:ext cx="3675888" cy="3063240"/>
+          </a:xfrm>
+          <a:prstGeom prst="roundRect">
+            <a:avLst>
+              <a:gd name="adj" fmla="val 2687"/>
+            </a:avLst>
+          </a:prstGeom>
+          <a:solidFill>
+            <a:srgbClr val="13273D"/>
+          </a:solidFill>
+          <a:ln w="9525">
+            <a:solidFill>
+              <a:srgbClr val="2C4A6B"/>
+            </a:solidFill>
+            <a:prstDash val="solid"/>
+          </a:ln>
+        </p:spPr>
+      </p:sp>
+      <p:sp>
+        <p:nvSpPr>
+          <p:cNvPr id="12" name="Shape 10"/>
+          <p:cNvSpPr/>
+          <p:nvPr/>
+        </p:nvSpPr>
+        <p:spPr>
+          <a:xfrm>
+            <a:off x="4572000" y="2240280"/>
+            <a:ext cx="1188720" cy="310896"/>
+          </a:xfrm>
+          <a:prstGeom prst="roundRect">
+            <a:avLst>
+              <a:gd name="adj" fmla="val 50000"/>
+            </a:avLst>
+          </a:prstGeom>
+          <a:solidFill>
+            <a:srgbClr val="BC8CFF"/>
+          </a:solidFill>
+          <a:ln/>
+        </p:spPr>
+      </p:sp>
+      <p:sp>
+        <p:nvSpPr>
+          <p:cNvPr id="13" name="Text 11"/>
+          <p:cNvSpPr/>
+          <p:nvPr/>
+        </p:nvSpPr>
+        <p:spPr>
+          <a:xfrm>
+            <a:off x="4572000" y="2232965"/>
+            <a:ext cx="1188720" cy="329184"/>
+          </a:xfrm>
+          <a:prstGeom prst="rect">
+            <a:avLst/>
+          </a:prstGeom>
+          <a:noFill/>
+          <a:ln/>
+        </p:spPr>
+        <p:txBody>
+          <a:bodyPr wrap="square" lIns="0" tIns="0" rIns="0" bIns="0" rtlCol="0" anchor="ctr"/>
+          <a:lstStyle/>
+          <a:p>
+            <a:pPr algn="ctr" indent="0" marL="0">
+              <a:buNone/>
+            </a:pPr>
+            <a:r>
+              <a:rPr lang="en-US" sz="1150" b="1" dirty="0">
+                <a:solidFill>
+                  <a:srgbClr val="0B1626"/>
+                </a:solidFill>
+                <a:latin typeface="Calibri" pitchFamily="34" charset="0"/>
+                <a:ea typeface="Calibri" pitchFamily="34" charset="-122"/>
+                <a:cs typeface="Calibri" pitchFamily="34" charset="-120"/>
+              </a:rPr>
+              <a:t>MOIS 2</a:t>
+            </a:r>
+            <a:endParaRPr lang="en-US" sz="1150" dirty="0"/>
+          </a:p>
+        </p:txBody>
+      </p:sp>
+      <p:sp>
+        <p:nvSpPr>
+          <p:cNvPr id="14" name="Text 12"/>
+          <p:cNvSpPr/>
+          <p:nvPr/>
+        </p:nvSpPr>
+        <p:spPr>
+          <a:xfrm>
+            <a:off x="4572000" y="2724912"/>
+            <a:ext cx="3246120" cy="2240280"/>
+          </a:xfrm>
+          <a:prstGeom prst="rect">
+            <a:avLst/>
+          </a:prstGeom>
+          <a:noFill/>
+          <a:ln/>
+        </p:spPr>
+        <p:txBody>
+          <a:bodyPr wrap="square" lIns="0" tIns="0" rIns="0" bIns="0" rtlCol="0" anchor="t"/>
+          <a:lstStyle/>
+          <a:p>
+            <a:pPr indent="0" marL="0">
+              <a:buNone/>
+            </a:pPr>
+            <a:r>
+              <a:rPr lang="en-US" sz="1080" b="1" dirty="0">
+                <a:solidFill>
+                  <a:srgbClr val="BC8CFF"/>
+                </a:solidFill>
+                <a:latin typeface="Calibri" pitchFamily="34" charset="0"/>
+                <a:ea typeface="Calibri" pitchFamily="34" charset="-122"/>
+                <a:cs typeface="Calibri" pitchFamily="34" charset="-120"/>
+              </a:rPr>
+              <a:t>Semaines 5-6 — </a:t>
+            </a:r>
+            <a:pPr indent="0" marL="0">
+              <a:spcAft>
+                <a:spcPts val="900"/>
+              </a:spcAft>
+              <a:buNone/>
+            </a:pPr>
+            <a:r>
+              <a:rPr lang="en-US" sz="1080" dirty="0">
+                <a:solidFill>
+                  <a:srgbClr val="EAF2FB"/>
+                </a:solidFill>
+                <a:latin typeface="Calibri" pitchFamily="34" charset="0"/>
+                <a:ea typeface="Calibri" pitchFamily="34" charset="-122"/>
+                <a:cs typeface="Calibri" pitchFamily="34" charset="-120"/>
+              </a:rPr>
+              <a:t>/rapport en production sur les contrats d'études en cours ; métrique heures-par-étude, avant / après.</a:t>
+            </a:r>
+            <a:endParaRPr lang="en-US" sz="1080" dirty="0"/>
+          </a:p>
+          <a:p>
+            <a:pPr indent="0" marL="0">
+              <a:buNone/>
+            </a:pPr>
+            <a:r>
+              <a:rPr lang="en-US" sz="1080" b="1" dirty="0">
+                <a:solidFill>
+                  <a:srgbClr val="BC8CFF"/>
+                </a:solidFill>
+                <a:latin typeface="Calibri" pitchFamily="34" charset="0"/>
+                <a:ea typeface="Calibri" pitchFamily="34" charset="-122"/>
+                <a:cs typeface="Calibri" pitchFamily="34" charset="-120"/>
+              </a:rPr>
+              <a:t>Semaines 7-8 — </a:t>
+            </a:r>
+            <a:pPr indent="0" marL="0">
+              <a:spcAft>
+                <a:spcPts val="900"/>
+              </a:spcAft>
+              <a:buNone/>
+            </a:pPr>
+            <a:r>
+              <a:rPr lang="en-US" sz="1080" dirty="0">
+                <a:solidFill>
+                  <a:srgbClr val="EAF2FB"/>
+                </a:solidFill>
+                <a:latin typeface="Calibri" pitchFamily="34" charset="0"/>
+                <a:ea typeface="Calibri" pitchFamily="34" charset="-122"/>
+                <a:cs typeface="Calibri" pitchFamily="34" charset="-120"/>
+              </a:rPr>
+              <a:t>Mobitec hors du mode gabarit : campagne capture-diff contre l'éditeur vendeur.</a:t>
+            </a:r>
+            <a:endParaRPr lang="en-US" sz="1080" dirty="0"/>
+          </a:p>
+        </p:txBody>
+      </p:sp>
+      <p:sp>
+        <p:nvSpPr>
+          <p:cNvPr id="15" name="Shape 13"/>
+          <p:cNvSpPr/>
+          <p:nvPr/>
+        </p:nvSpPr>
+        <p:spPr>
+          <a:xfrm>
+            <a:off x="8183880" y="2011680"/>
+            <a:ext cx="3675888" cy="3063240"/>
+          </a:xfrm>
+          <a:prstGeom prst="roundRect">
+            <a:avLst>
+              <a:gd name="adj" fmla="val 2687"/>
+            </a:avLst>
+          </a:prstGeom>
+          <a:solidFill>
+            <a:srgbClr val="13273D"/>
+          </a:solidFill>
+          <a:ln w="9525">
+            <a:solidFill>
+              <a:srgbClr val="2C4A6B"/>
+            </a:solidFill>
+            <a:prstDash val="solid"/>
+          </a:ln>
+        </p:spPr>
+      </p:sp>
+      <p:sp>
+        <p:nvSpPr>
+          <p:cNvPr id="16" name="Shape 14"/>
+          <p:cNvSpPr/>
+          <p:nvPr/>
+        </p:nvSpPr>
+        <p:spPr>
+          <a:xfrm>
+            <a:off x="8412480" y="2240280"/>
+            <a:ext cx="1188720" cy="310896"/>
+          </a:xfrm>
+          <a:prstGeom prst="roundRect">
+            <a:avLst>
+              <a:gd name="adj" fmla="val 50000"/>
+            </a:avLst>
+          </a:prstGeom>
+          <a:solidFill>
+            <a:srgbClr val="3FCF6E"/>
+          </a:solidFill>
+          <a:ln/>
+        </p:spPr>
+      </p:sp>
+      <p:sp>
+        <p:nvSpPr>
+          <p:cNvPr id="17" name="Text 15"/>
+          <p:cNvSpPr/>
+          <p:nvPr/>
+        </p:nvSpPr>
+        <p:spPr>
+          <a:xfrm>
+            <a:off x="8412480" y="2232965"/>
+            <a:ext cx="1188720" cy="329184"/>
+          </a:xfrm>
+          <a:prstGeom prst="rect">
+            <a:avLst/>
+          </a:prstGeom>
+          <a:noFill/>
+          <a:ln/>
+        </p:spPr>
+        <p:txBody>
+          <a:bodyPr wrap="square" lIns="0" tIns="0" rIns="0" bIns="0" rtlCol="0" anchor="ctr"/>
+          <a:lstStyle/>
+          <a:p>
+            <a:pPr algn="ctr" indent="0" marL="0">
+              <a:buNone/>
+            </a:pPr>
+            <a:r>
+              <a:rPr lang="en-US" sz="1150" b="1" dirty="0">
+                <a:solidFill>
+                  <a:srgbClr val="0B1626"/>
+                </a:solidFill>
+                <a:latin typeface="Calibri" pitchFamily="34" charset="0"/>
+                <a:ea typeface="Calibri" pitchFamily="34" charset="-122"/>
+                <a:cs typeface="Calibri" pitchFamily="34" charset="-120"/>
+              </a:rPr>
+              <a:t>MOIS 3</a:t>
+            </a:r>
+            <a:endParaRPr lang="en-US" sz="1150" dirty="0"/>
+          </a:p>
+        </p:txBody>
+      </p:sp>
+      <p:sp>
+        <p:nvSpPr>
+          <p:cNvPr id="18" name="Text 16"/>
+          <p:cNvSpPr/>
+          <p:nvPr/>
+        </p:nvSpPr>
+        <p:spPr>
+          <a:xfrm>
+            <a:off x="8412480" y="2724912"/>
+            <a:ext cx="3246120" cy="2240280"/>
+          </a:xfrm>
+          <a:prstGeom prst="rect">
+            <a:avLst/>
+          </a:prstGeom>
+          <a:noFill/>
+          <a:ln/>
+        </p:spPr>
+        <p:txBody>
+          <a:bodyPr wrap="square" lIns="0" tIns="0" rIns="0" bIns="0" rtlCol="0" anchor="t"/>
+          <a:lstStyle/>
+          <a:p>
+            <a:pPr indent="0" marL="0">
+              <a:buNone/>
+            </a:pPr>
+            <a:r>
+              <a:rPr lang="en-US" sz="1080" b="1" dirty="0">
+                <a:solidFill>
+                  <a:srgbClr val="3FCF6E"/>
+                </a:solidFill>
+                <a:latin typeface="Calibri" pitchFamily="34" charset="0"/>
+                <a:ea typeface="Calibri" pitchFamily="34" charset="-122"/>
+                <a:cs typeface="Calibri" pitchFamily="34" charset="-120"/>
+              </a:rPr>
+              <a:t>Semaines 9-10 — </a:t>
+            </a:r>
+            <a:pPr indent="0" marL="0">
+              <a:spcAft>
+                <a:spcPts val="900"/>
+              </a:spcAft>
+              <a:buNone/>
+            </a:pPr>
+            <a:r>
+              <a:rPr lang="en-US" sz="1080" dirty="0">
+                <a:solidFill>
+                  <a:srgbClr val="EAF2FB"/>
+                </a:solidFill>
+                <a:latin typeface="Calibri" pitchFamily="34" charset="0"/>
+                <a:ea typeface="Calibri" pitchFamily="34" charset="-122"/>
+                <a:cs typeface="Calibri" pitchFamily="34" charset="-120"/>
+              </a:rPr>
+              <a:t>flux &amp; santé rapport branchés dans la routine COPIL — les deux questions que le comité pose vraiment.</a:t>
+            </a:r>
+            <a:endParaRPr lang="en-US" sz="1080" dirty="0"/>
+          </a:p>
+          <a:p>
+            <a:pPr indent="0" marL="0">
+              <a:buNone/>
+            </a:pPr>
+            <a:r>
+              <a:rPr lang="en-US" sz="1080" b="1" dirty="0">
+                <a:solidFill>
+                  <a:srgbClr val="3FCF6E"/>
+                </a:solidFill>
+                <a:latin typeface="Calibri" pitchFamily="34" charset="0"/>
+                <a:ea typeface="Calibri" pitchFamily="34" charset="-122"/>
+                <a:cs typeface="Calibri" pitchFamily="34" charset="-120"/>
+              </a:rPr>
+              <a:t>Semaines 11-12 — </a:t>
+            </a:r>
+            <a:pPr indent="0" marL="0">
+              <a:spcAft>
+                <a:spcPts val="900"/>
+              </a:spcAft>
+              <a:buNone/>
+            </a:pPr>
+            <a:r>
+              <a:rPr lang="en-US" sz="1080" dirty="0">
+                <a:solidFill>
+                  <a:srgbClr val="EAF2FB"/>
+                </a:solidFill>
+                <a:latin typeface="Calibri" pitchFamily="34" charset="0"/>
+                <a:ea typeface="Calibri" pitchFamily="34" charset="-122"/>
+                <a:cs typeface="Calibri" pitchFamily="34" charset="-120"/>
+              </a:rPr>
+              <a:t>transfert : playbooks à jour, formation courte à l'équipe, bilan chiffré de chaque mission.</a:t>
+            </a:r>
+            <a:endParaRPr lang="en-US" sz="1080" dirty="0"/>
+          </a:p>
+          <a:p>
+            <a:pPr indent="0" marL="0">
+              <a:buNone/>
+            </a:pPr>
+            <a:r>
+              <a:rPr lang="en-US" sz="1080" b="1" dirty="0">
+                <a:solidFill>
+                  <a:srgbClr val="3FCF6E"/>
+                </a:solidFill>
+                <a:latin typeface="Calibri" pitchFamily="34" charset="0"/>
+                <a:ea typeface="Calibri" pitchFamily="34" charset="-122"/>
+                <a:cs typeface="Calibri" pitchFamily="34" charset="-120"/>
+              </a:rPr>
+              <a:t>Bonus — </a:t>
+            </a:r>
+            <a:pPr indent="0" marL="0">
+              <a:spcAft>
+                <a:spcPts val="900"/>
+              </a:spcAft>
+              <a:buNone/>
+            </a:pPr>
+            <a:r>
+              <a:rPr lang="en-US" sz="1080" dirty="0">
+                <a:solidFill>
+                  <a:srgbClr val="EAF2FB"/>
+                </a:solidFill>
+                <a:latin typeface="Calibri" pitchFamily="34" charset="0"/>
+                <a:ea typeface="Calibri" pitchFamily="34" charset="-122"/>
+                <a:cs typeface="Calibri" pitchFamily="34" charset="-120"/>
+              </a:rPr>
+              <a:t>premier essai de photogrammétrie sur un site pilote — la prochaine histoire commence.</a:t>
+            </a:r>
+            <a:endParaRPr lang="en-US" sz="1080" dirty="0"/>
+          </a:p>
+        </p:txBody>
+      </p:sp>
+      <p:sp>
+        <p:nvSpPr>
+          <p:cNvPr id="19" name="Shape 17"/>
+          <p:cNvSpPr/>
+          <p:nvPr/>
+        </p:nvSpPr>
+        <p:spPr>
+          <a:xfrm>
+            <a:off x="502920" y="5257800"/>
+            <a:ext cx="11173968" cy="914400"/>
+          </a:xfrm>
+          <a:prstGeom prst="roundRect">
+            <a:avLst>
+              <a:gd name="adj" fmla="val 9000"/>
+            </a:avLst>
+          </a:prstGeom>
+          <a:solidFill>
+            <a:srgbClr val="1A3350"/>
+          </a:solidFill>
+          <a:ln w="9525">
+            <a:solidFill>
+              <a:srgbClr val="2C4A6B"/>
+            </a:solidFill>
+            <a:prstDash val="solid"/>
+          </a:ln>
+        </p:spPr>
+      </p:sp>
+      <p:sp>
+        <p:nvSpPr>
+          <p:cNvPr id="20" name="Text 18"/>
+          <p:cNvSpPr/>
+          <p:nvPr/>
+        </p:nvSpPr>
+        <p:spPr>
+          <a:xfrm>
+            <a:off x="822960" y="5486400"/>
+            <a:ext cx="10515600" cy="548640"/>
+          </a:xfrm>
+          <a:prstGeom prst="rect">
+            <a:avLst/>
+          </a:prstGeom>
+          <a:noFill/>
+          <a:ln/>
+        </p:spPr>
+        <p:txBody>
+          <a:bodyPr wrap="square" lIns="0" tIns="0" rIns="0" bIns="0" rtlCol="0" anchor="t"/>
+          <a:lstStyle/>
+          <a:p>
+            <a:pPr indent="0" marL="0">
+              <a:buNone/>
+            </a:pPr>
+            <a:r>
+              <a:rPr lang="en-US" sz="1250" b="1" dirty="0">
+                <a:solidFill>
+                  <a:srgbClr val="3FCF6E"/>
+                </a:solidFill>
+                <a:latin typeface="Calibri" pitchFamily="34" charset="0"/>
+                <a:ea typeface="Calibri" pitchFamily="34" charset="-122"/>
+                <a:cs typeface="Calibri" pitchFamily="34" charset="-120"/>
+              </a:rPr>
+              <a:t>Le cadre : </a:t>
+            </a:r>
+            <a:pPr indent="0" marL="0">
+              <a:buNone/>
+            </a:pPr>
+            <a:r>
+              <a:rPr lang="en-US" sz="1250" dirty="0">
+                <a:solidFill>
+                  <a:srgbClr val="EAF2FB"/>
+                </a:solidFill>
+                <a:latin typeface="Calibri" pitchFamily="34" charset="0"/>
+                <a:ea typeface="Calibri" pitchFamily="34" charset="-122"/>
+                <a:cs typeface="Calibri" pitchFamily="34" charset="-120"/>
+              </a:rPr>
+              <a:t>objectifs écrits, point d'étape toutes les deux semaines, livrables mesurés — et le suivi de progression documente déjà tout en Problème → Action → Apprentissage, preuves à l'appui.</a:t>
+            </a:r>
+            <a:endParaRPr lang="en-US" sz="1250" dirty="0"/>
+          </a:p>
+        </p:txBody>
+      </p:sp>
+    </p:spTree>
+  </p:cSld>
+  <p:clrMapOvr>
+    <a:masterClrMapping/>
+  </p:clrMapOvr>
+</p:sld>
+</file>
+
+<file path=ppt/slides/slide15.xml><?xml version="1.0" encoding="utf-8"?>
+<p:sld xmlns:a="http://schemas.openxmlformats.org/drawingml/2006/main" xmlns:r="http://schemas.openxmlformats.org/officeDocument/2006/relationships" xmlns:p="http://schemas.openxmlformats.org/presentationml/2006/main">
+  <p:cSld name="Slide 15">
+    <p:bg>
+      <p:bgPr>
+        <a:solidFill>
+          <a:srgbClr val="0B1626"/>
+        </a:solidFill>
+      </p:bgPr>
+    </p:bg>
+    <p:spTree>
+      <p:nvGrpSpPr>
+        <p:cNvPr id="1" name=""/>
+        <p:cNvGrpSpPr/>
+        <p:nvPr/>
+      </p:nvGrpSpPr>
+      <p:grpSpPr>
+        <a:xfrm>
+          <a:off x="0" y="0"/>
+          <a:ext cx="0" cy="0"/>
+          <a:chOff x="0" y="0"/>
+          <a:chExt cx="0" cy="0"/>
+        </a:xfrm>
+      </p:grpSpPr>
+      <p:sp>
+        <p:nvSpPr>
+          <p:cNvPr id="2" name="Text 0"/>
+          <p:cNvSpPr/>
+          <p:nvPr/>
+        </p:nvSpPr>
+        <p:spPr>
+          <a:xfrm>
+            <a:off x="502920" y="6473952"/>
+            <a:ext cx="9601200" cy="274320"/>
+          </a:xfrm>
+          <a:prstGeom prst="rect">
+            <a:avLst/>
+          </a:prstGeom>
+          <a:noFill/>
+          <a:ln/>
+        </p:spPr>
+        <p:txBody>
+          <a:bodyPr wrap="square" lIns="0" tIns="0" rIns="0" bIns="0" rtlCol="0" anchor="ctr"/>
+          <a:lstStyle/>
+          <a:p>
+            <a:pPr indent="0" marL="0">
+              <a:buNone/>
+            </a:pPr>
+            <a:r>
+              <a:rPr lang="en-US" sz="850" dirty="0">
+                <a:solidFill>
+                  <a:srgbClr val="9DB2C7"/>
+                </a:solidFill>
+                <a:latin typeface="Calibri" pitchFamily="34" charset="0"/>
+                <a:ea typeface="Calibri" pitchFamily="34" charset="-122"/>
+                <a:cs typeface="Calibri" pitchFamily="34" charset="-120"/>
+              </a:rPr>
+              <a:t>SVT COMMUNICATION  /  PROBLEME - ACTION - APPRIS  /  JULIEN ABDOU GONZALES</a:t>
+            </a:r>
+            <a:endParaRPr lang="en-US" sz="850" dirty="0"/>
+          </a:p>
+        </p:txBody>
+      </p:sp>
+      <p:sp>
+        <p:nvSpPr>
+          <p:cNvPr id="3" name="Text 1"/>
+          <p:cNvSpPr/>
+          <p:nvPr/>
+        </p:nvSpPr>
+        <p:spPr>
+          <a:xfrm>
+            <a:off x="11475720" y="6473952"/>
+            <a:ext cx="365760" cy="274320"/>
+          </a:xfrm>
+          <a:prstGeom prst="rect">
+            <a:avLst/>
+          </a:prstGeom>
+          <a:noFill/>
+          <a:ln/>
+        </p:spPr>
+        <p:txBody>
+          <a:bodyPr wrap="square" lIns="0" tIns="0" rIns="0" bIns="0" rtlCol="0" anchor="ctr"/>
+          <a:lstStyle/>
+          <a:p>
+            <a:pPr algn="r" indent="0" marL="0">
+              <a:buNone/>
+            </a:pPr>
+            <a:r>
+              <a:rPr lang="en-US" sz="850" dirty="0">
+                <a:solidFill>
+                  <a:srgbClr val="9DB2C7"/>
+                </a:solidFill>
+                <a:latin typeface="Calibri" pitchFamily="34" charset="0"/>
+                <a:ea typeface="Calibri" pitchFamily="34" charset="-122"/>
+                <a:cs typeface="Calibri" pitchFamily="34" charset="-120"/>
+              </a:rPr>
+              <a:t>15</a:t>
+            </a:r>
+            <a:endParaRPr lang="en-US" sz="850" dirty="0"/>
+          </a:p>
+        </p:txBody>
+      </p:sp>
+      <p:sp>
+        <p:nvSpPr>
+          <p:cNvPr id="4" name="Text 2"/>
+          <p:cNvSpPr/>
+          <p:nvPr/>
+        </p:nvSpPr>
+        <p:spPr>
+          <a:xfrm>
             <a:off x="822960" y="1828800"/>
             <a:ext cx="10515600" cy="822960"/>
           </a:xfrm>
@@ -10713,14 +11651,53 @@
       </p:sp>
       <p:sp>
         <p:nvSpPr>
-          <p:cNvPr id="6" name="Shape 4"/>
-          <p:cNvSpPr/>
-          <p:nvPr/>
-        </p:nvSpPr>
-        <p:spPr>
-          <a:xfrm>
-            <a:off x="502920" y="1463040"/>
-            <a:ext cx="3675888" cy="4160520"/>
+          <p:cNvPr id="6" name="Text 4"/>
+          <p:cNvSpPr/>
+          <p:nvPr/>
+        </p:nvSpPr>
+        <p:spPr>
+          <a:xfrm>
+            <a:off x="502920" y="1298448"/>
+            <a:ext cx="11155680" cy="457200"/>
+          </a:xfrm>
+          <a:prstGeom prst="rect">
+            <a:avLst/>
+          </a:prstGeom>
+          <a:noFill/>
+          <a:ln/>
+        </p:spPr>
+        <p:txBody>
+          <a:bodyPr wrap="square" lIns="0" tIns="0" rIns="0" bIns="0" rtlCol="0" anchor="ctr"/>
+          <a:lstStyle/>
+          <a:p>
+            <a:pPr indent="0" marL="0">
+              <a:buNone/>
+            </a:pPr>
+            <a:r>
+              <a:rPr lang="en-US" sz="1350" dirty="0">
+                <a:solidFill>
+                  <a:srgbClr val="9DB2C7"/>
+                </a:solidFill>
+                <a:latin typeface="Calibri" pitchFamily="34" charset="0"/>
+                <a:ea typeface="Calibri" pitchFamily="34" charset="-122"/>
+                <a:cs typeface="Calibri" pitchFamily="34" charset="-120"/>
+              </a:rPr>
+              <a:t>Le chantier est fini, mais le livrable attend la rédaction — chaque heure d'écriture est une heure de facturation qui attend.</a:t>
+            </a:r>
+            <a:endParaRPr lang="en-US" sz="1350" dirty="0"/>
+          </a:p>
+        </p:txBody>
+      </p:sp>
+      <p:sp>
+        <p:nvSpPr>
+          <p:cNvPr id="7" name="Shape 5"/>
+          <p:cNvSpPr/>
+          <p:nvPr/>
+        </p:nvSpPr>
+        <p:spPr>
+          <a:xfrm>
+            <a:off x="502920" y="1783080"/>
+            <a:ext cx="3675888" cy="3840480"/>
           </a:xfrm>
           <a:prstGeom prst="roundRect">
             <a:avLst>
@@ -10740,13 +11717,13 @@
       </p:sp>
       <p:sp>
         <p:nvSpPr>
-          <p:cNvPr id="7" name="Shape 5"/>
-          <p:cNvSpPr/>
-          <p:nvPr/>
-        </p:nvSpPr>
-        <p:spPr>
-          <a:xfrm>
-            <a:off x="731520" y="1664208"/>
+          <p:cNvPr id="8" name="Shape 6"/>
+          <p:cNvSpPr/>
+          <p:nvPr/>
+        </p:nvSpPr>
+        <p:spPr>
+          <a:xfrm>
+            <a:off x="731520" y="1984248"/>
             <a:ext cx="1371600" cy="310896"/>
           </a:xfrm>
           <a:prstGeom prst="roundRect">
@@ -10762,13 +11739,13 @@
       </p:sp>
       <p:sp>
         <p:nvSpPr>
-          <p:cNvPr id="8" name="Text 6"/>
-          <p:cNvSpPr/>
-          <p:nvPr/>
-        </p:nvSpPr>
-        <p:spPr>
-          <a:xfrm>
-            <a:off x="731520" y="1656893"/>
+          <p:cNvPr id="9" name="Text 7"/>
+          <p:cNvSpPr/>
+          <p:nvPr/>
+        </p:nvSpPr>
+        <p:spPr>
+          <a:xfrm>
+            <a:off x="731520" y="1976933"/>
             <a:ext cx="1371600" cy="329184"/>
           </a:xfrm>
           <a:prstGeom prst="rect">
@@ -10801,14 +11778,14 @@
       </p:sp>
       <p:sp>
         <p:nvSpPr>
-          <p:cNvPr id="9" name="Text 7"/>
-          <p:cNvSpPr/>
-          <p:nvPr/>
-        </p:nvSpPr>
-        <p:spPr>
-          <a:xfrm>
-            <a:off x="731520" y="2148840"/>
-            <a:ext cx="3218688" cy="3291840"/>
+          <p:cNvPr id="10" name="Text 8"/>
+          <p:cNvSpPr/>
+          <p:nvPr/>
+        </p:nvSpPr>
+        <p:spPr>
+          <a:xfrm>
+            <a:off x="731520" y="2468880"/>
+            <a:ext cx="3218688" cy="2971800"/>
           </a:xfrm>
           <a:prstGeom prst="rect">
             <a:avLst/>
@@ -10883,14 +11860,14 @@
       </p:sp>
       <p:sp>
         <p:nvSpPr>
-          <p:cNvPr id="10" name="Shape 8"/>
-          <p:cNvSpPr/>
-          <p:nvPr/>
-        </p:nvSpPr>
-        <p:spPr>
-          <a:xfrm>
-            <a:off x="4343400" y="1463040"/>
-            <a:ext cx="3675888" cy="4160520"/>
+          <p:cNvPr id="11" name="Shape 9"/>
+          <p:cNvSpPr/>
+          <p:nvPr/>
+        </p:nvSpPr>
+        <p:spPr>
+          <a:xfrm>
+            <a:off x="4343400" y="1783080"/>
+            <a:ext cx="3675888" cy="3840480"/>
           </a:xfrm>
           <a:prstGeom prst="roundRect">
             <a:avLst>
@@ -10910,13 +11887,13 @@
       </p:sp>
       <p:sp>
         <p:nvSpPr>
-          <p:cNvPr id="11" name="Shape 9"/>
-          <p:cNvSpPr/>
-          <p:nvPr/>
-        </p:nvSpPr>
-        <p:spPr>
-          <a:xfrm>
-            <a:off x="4572000" y="1664208"/>
+          <p:cNvPr id="12" name="Shape 10"/>
+          <p:cNvSpPr/>
+          <p:nvPr/>
+        </p:nvSpPr>
+        <p:spPr>
+          <a:xfrm>
+            <a:off x="4572000" y="1984248"/>
             <a:ext cx="1371600" cy="310896"/>
           </a:xfrm>
           <a:prstGeom prst="roundRect">
@@ -10932,13 +11909,13 @@
       </p:sp>
       <p:sp>
         <p:nvSpPr>
-          <p:cNvPr id="12" name="Text 10"/>
-          <p:cNvSpPr/>
-          <p:nvPr/>
-        </p:nvSpPr>
-        <p:spPr>
-          <a:xfrm>
-            <a:off x="4572000" y="1656893"/>
+          <p:cNvPr id="13" name="Text 11"/>
+          <p:cNvSpPr/>
+          <p:nvPr/>
+        </p:nvSpPr>
+        <p:spPr>
+          <a:xfrm>
+            <a:off x="4572000" y="1976933"/>
             <a:ext cx="1371600" cy="329184"/>
           </a:xfrm>
           <a:prstGeom prst="rect">
@@ -10971,14 +11948,14 @@
       </p:sp>
       <p:sp>
         <p:nvSpPr>
-          <p:cNvPr id="13" name="Text 11"/>
-          <p:cNvSpPr/>
-          <p:nvPr/>
-        </p:nvSpPr>
-        <p:spPr>
-          <a:xfrm>
-            <a:off x="4572000" y="2148840"/>
-            <a:ext cx="3218688" cy="3291840"/>
+          <p:cNvPr id="14" name="Text 12"/>
+          <p:cNvSpPr/>
+          <p:nvPr/>
+        </p:nvSpPr>
+        <p:spPr>
+          <a:xfrm>
+            <a:off x="4572000" y="2468880"/>
+            <a:ext cx="3218688" cy="2971800"/>
           </a:xfrm>
           <a:prstGeom prst="rect">
             <a:avLst/>
@@ -11053,14 +12030,14 @@
       </p:sp>
       <p:sp>
         <p:nvSpPr>
-          <p:cNvPr id="14" name="Shape 12"/>
-          <p:cNvSpPr/>
-          <p:nvPr/>
-        </p:nvSpPr>
-        <p:spPr>
-          <a:xfrm>
-            <a:off x="8183880" y="1463040"/>
-            <a:ext cx="3675888" cy="4160520"/>
+          <p:cNvPr id="15" name="Shape 13"/>
+          <p:cNvSpPr/>
+          <p:nvPr/>
+        </p:nvSpPr>
+        <p:spPr>
+          <a:xfrm>
+            <a:off x="8183880" y="1783080"/>
+            <a:ext cx="3675888" cy="3840480"/>
           </a:xfrm>
           <a:prstGeom prst="roundRect">
             <a:avLst>
@@ -11080,13 +12057,13 @@
       </p:sp>
       <p:sp>
         <p:nvSpPr>
-          <p:cNvPr id="15" name="Shape 13"/>
-          <p:cNvSpPr/>
-          <p:nvPr/>
-        </p:nvSpPr>
-        <p:spPr>
-          <a:xfrm>
-            <a:off x="8412480" y="1664208"/>
+          <p:cNvPr id="16" name="Shape 14"/>
+          <p:cNvSpPr/>
+          <p:nvPr/>
+        </p:nvSpPr>
+        <p:spPr>
+          <a:xfrm>
+            <a:off x="8412480" y="1984248"/>
             <a:ext cx="1371600" cy="310896"/>
           </a:xfrm>
           <a:prstGeom prst="roundRect">
@@ -11102,13 +12079,13 @@
       </p:sp>
       <p:sp>
         <p:nvSpPr>
-          <p:cNvPr id="16" name="Text 14"/>
-          <p:cNvSpPr/>
-          <p:nvPr/>
-        </p:nvSpPr>
-        <p:spPr>
-          <a:xfrm>
-            <a:off x="8412480" y="1656893"/>
+          <p:cNvPr id="17" name="Text 15"/>
+          <p:cNvSpPr/>
+          <p:nvPr/>
+        </p:nvSpPr>
+        <p:spPr>
+          <a:xfrm>
+            <a:off x="8412480" y="1976933"/>
             <a:ext cx="1371600" cy="329184"/>
           </a:xfrm>
           <a:prstGeom prst="rect">
@@ -11141,14 +12118,14 @@
       </p:sp>
       <p:sp>
         <p:nvSpPr>
-          <p:cNvPr id="17" name="Text 15"/>
-          <p:cNvSpPr/>
-          <p:nvPr/>
-        </p:nvSpPr>
-        <p:spPr>
-          <a:xfrm>
-            <a:off x="8412480" y="2148840"/>
-            <a:ext cx="3218688" cy="3291840"/>
+          <p:cNvPr id="18" name="Text 16"/>
+          <p:cNvSpPr/>
+          <p:nvPr/>
+        </p:nvSpPr>
+        <p:spPr>
+          <a:xfrm>
+            <a:off x="8412480" y="2468880"/>
+            <a:ext cx="3218688" cy="2971800"/>
           </a:xfrm>
           <a:prstGeom prst="rect">
             <a:avLst/>
@@ -11223,7 +12200,7 @@
       </p:sp>
       <p:sp>
         <p:nvSpPr>
-          <p:cNvPr id="18" name="Text 16"/>
+          <p:cNvPr id="19" name="Text 17"/>
           <p:cNvSpPr/>
           <p:nvPr/>
         </p:nvSpPr>
@@ -11450,14 +12427,53 @@
       </p:sp>
       <p:sp>
         <p:nvSpPr>
-          <p:cNvPr id="6" name="Shape 4"/>
-          <p:cNvSpPr/>
-          <p:nvPr/>
-        </p:nvSpPr>
-        <p:spPr>
-          <a:xfrm>
-            <a:off x="502920" y="1463040"/>
-            <a:ext cx="3675888" cy="4160520"/>
+          <p:cNvPr id="6" name="Text 4"/>
+          <p:cNvSpPr/>
+          <p:nvPr/>
+        </p:nvSpPr>
+        <p:spPr>
+          <a:xfrm>
+            <a:off x="502920" y="1298448"/>
+            <a:ext cx="11155680" cy="457200"/>
+          </a:xfrm>
+          <a:prstGeom prst="rect">
+            <a:avLst/>
+          </a:prstGeom>
+          <a:noFill/>
+          <a:ln/>
+        </p:spPr>
+        <p:txBody>
+          <a:bodyPr wrap="square" lIns="0" tIns="0" rIns="0" bIns="0" rtlCol="0" anchor="ctr"/>
+          <a:lstStyle/>
+          <a:p>
+            <a:pPr indent="0" marL="0">
+              <a:buNone/>
+            </a:pPr>
+            <a:r>
+              <a:rPr lang="en-US" sz="1350" dirty="0">
+                <a:solidFill>
+                  <a:srgbClr val="9DB2C7"/>
+                </a:solidFill>
+                <a:latin typeface="Calibri" pitchFamily="34" charset="0"/>
+                <a:ea typeface="Calibri" pitchFamily="34" charset="-122"/>
+                <a:cs typeface="Calibri" pitchFamily="34" charset="-120"/>
+              </a:rPr>
+              <a:t>« C'est quel CO, déjà ? » — personne ne devrait avoir à mémoriser un identifiant pour savoir où en est un chantier.</a:t>
+            </a:r>
+            <a:endParaRPr lang="en-US" sz="1350" dirty="0"/>
+          </a:p>
+        </p:txBody>
+      </p:sp>
+      <p:sp>
+        <p:nvSpPr>
+          <p:cNvPr id="7" name="Shape 5"/>
+          <p:cNvSpPr/>
+          <p:nvPr/>
+        </p:nvSpPr>
+        <p:spPr>
+          <a:xfrm>
+            <a:off x="502920" y="1783080"/>
+            <a:ext cx="3675888" cy="3840480"/>
           </a:xfrm>
           <a:prstGeom prst="roundRect">
             <a:avLst>
@@ -11477,13 +12493,13 @@
       </p:sp>
       <p:sp>
         <p:nvSpPr>
-          <p:cNvPr id="7" name="Shape 5"/>
-          <p:cNvSpPr/>
-          <p:nvPr/>
-        </p:nvSpPr>
-        <p:spPr>
-          <a:xfrm>
-            <a:off x="731520" y="1664208"/>
+          <p:cNvPr id="8" name="Shape 6"/>
+          <p:cNvSpPr/>
+          <p:nvPr/>
+        </p:nvSpPr>
+        <p:spPr>
+          <a:xfrm>
+            <a:off x="731520" y="1984248"/>
             <a:ext cx="1371600" cy="310896"/>
           </a:xfrm>
           <a:prstGeom prst="roundRect">
@@ -11499,13 +12515,13 @@
       </p:sp>
       <p:sp>
         <p:nvSpPr>
-          <p:cNvPr id="8" name="Text 6"/>
-          <p:cNvSpPr/>
-          <p:nvPr/>
-        </p:nvSpPr>
-        <p:spPr>
-          <a:xfrm>
-            <a:off x="731520" y="1656893"/>
+          <p:cNvPr id="9" name="Text 7"/>
+          <p:cNvSpPr/>
+          <p:nvPr/>
+        </p:nvSpPr>
+        <p:spPr>
+          <a:xfrm>
+            <a:off x="731520" y="1976933"/>
             <a:ext cx="1371600" cy="329184"/>
           </a:xfrm>
           <a:prstGeom prst="rect">
@@ -11538,14 +12554,14 @@
       </p:sp>
       <p:sp>
         <p:nvSpPr>
-          <p:cNvPr id="9" name="Text 7"/>
-          <p:cNvSpPr/>
-          <p:nvPr/>
-        </p:nvSpPr>
-        <p:spPr>
-          <a:xfrm>
-            <a:off x="731520" y="2148840"/>
-            <a:ext cx="3218688" cy="3291840"/>
+          <p:cNvPr id="10" name="Text 8"/>
+          <p:cNvSpPr/>
+          <p:nvPr/>
+        </p:nvSpPr>
+        <p:spPr>
+          <a:xfrm>
+            <a:off x="731520" y="2468880"/>
+            <a:ext cx="3218688" cy="2971800"/>
           </a:xfrm>
           <a:prstGeom prst="rect">
             <a:avLst/>
@@ -11620,14 +12636,14 @@
       </p:sp>
       <p:sp>
         <p:nvSpPr>
-          <p:cNvPr id="10" name="Shape 8"/>
-          <p:cNvSpPr/>
-          <p:nvPr/>
-        </p:nvSpPr>
-        <p:spPr>
-          <a:xfrm>
-            <a:off x="4343400" y="1463040"/>
-            <a:ext cx="3675888" cy="4160520"/>
+          <p:cNvPr id="11" name="Shape 9"/>
+          <p:cNvSpPr/>
+          <p:nvPr/>
+        </p:nvSpPr>
+        <p:spPr>
+          <a:xfrm>
+            <a:off x="4343400" y="1783080"/>
+            <a:ext cx="3675888" cy="3840480"/>
           </a:xfrm>
           <a:prstGeom prst="roundRect">
             <a:avLst>
@@ -11647,13 +12663,13 @@
       </p:sp>
       <p:sp>
         <p:nvSpPr>
-          <p:cNvPr id="11" name="Shape 9"/>
-          <p:cNvSpPr/>
-          <p:nvPr/>
-        </p:nvSpPr>
-        <p:spPr>
-          <a:xfrm>
-            <a:off x="4572000" y="1664208"/>
+          <p:cNvPr id="12" name="Shape 10"/>
+          <p:cNvSpPr/>
+          <p:nvPr/>
+        </p:nvSpPr>
+        <p:spPr>
+          <a:xfrm>
+            <a:off x="4572000" y="1984248"/>
             <a:ext cx="1371600" cy="310896"/>
           </a:xfrm>
           <a:prstGeom prst="roundRect">
@@ -11669,13 +12685,13 @@
       </p:sp>
       <p:sp>
         <p:nvSpPr>
-          <p:cNvPr id="12" name="Text 10"/>
-          <p:cNvSpPr/>
-          <p:nvPr/>
-        </p:nvSpPr>
-        <p:spPr>
-          <a:xfrm>
-            <a:off x="4572000" y="1656893"/>
+          <p:cNvPr id="13" name="Text 11"/>
+          <p:cNvSpPr/>
+          <p:nvPr/>
+        </p:nvSpPr>
+        <p:spPr>
+          <a:xfrm>
+            <a:off x="4572000" y="1976933"/>
             <a:ext cx="1371600" cy="329184"/>
           </a:xfrm>
           <a:prstGeom prst="rect">
@@ -11708,14 +12724,14 @@
       </p:sp>
       <p:sp>
         <p:nvSpPr>
-          <p:cNvPr id="13" name="Text 11"/>
-          <p:cNvSpPr/>
-          <p:nvPr/>
-        </p:nvSpPr>
-        <p:spPr>
-          <a:xfrm>
-            <a:off x="4572000" y="2148840"/>
-            <a:ext cx="3218688" cy="3291840"/>
+          <p:cNvPr id="14" name="Text 12"/>
+          <p:cNvSpPr/>
+          <p:nvPr/>
+        </p:nvSpPr>
+        <p:spPr>
+          <a:xfrm>
+            <a:off x="4572000" y="2468880"/>
+            <a:ext cx="3218688" cy="2971800"/>
           </a:xfrm>
           <a:prstGeom prst="rect">
             <a:avLst/>
@@ -11790,14 +12806,14 @@
       </p:sp>
       <p:sp>
         <p:nvSpPr>
-          <p:cNvPr id="14" name="Shape 12"/>
-          <p:cNvSpPr/>
-          <p:nvPr/>
-        </p:nvSpPr>
-        <p:spPr>
-          <a:xfrm>
-            <a:off x="8183880" y="1463040"/>
-            <a:ext cx="3675888" cy="4160520"/>
+          <p:cNvPr id="15" name="Shape 13"/>
+          <p:cNvSpPr/>
+          <p:nvPr/>
+        </p:nvSpPr>
+        <p:spPr>
+          <a:xfrm>
+            <a:off x="8183880" y="1783080"/>
+            <a:ext cx="3675888" cy="3840480"/>
           </a:xfrm>
           <a:prstGeom prst="roundRect">
             <a:avLst>
@@ -11817,13 +12833,13 @@
       </p:sp>
       <p:sp>
         <p:nvSpPr>
-          <p:cNvPr id="15" name="Shape 13"/>
-          <p:cNvSpPr/>
-          <p:nvPr/>
-        </p:nvSpPr>
-        <p:spPr>
-          <a:xfrm>
-            <a:off x="8412480" y="1664208"/>
+          <p:cNvPr id="16" name="Shape 14"/>
+          <p:cNvSpPr/>
+          <p:nvPr/>
+        </p:nvSpPr>
+        <p:spPr>
+          <a:xfrm>
+            <a:off x="8412480" y="1984248"/>
             <a:ext cx="1371600" cy="310896"/>
           </a:xfrm>
           <a:prstGeom prst="roundRect">
@@ -11839,13 +12855,13 @@
       </p:sp>
       <p:sp>
         <p:nvSpPr>
-          <p:cNvPr id="16" name="Text 14"/>
-          <p:cNvSpPr/>
-          <p:nvPr/>
-        </p:nvSpPr>
-        <p:spPr>
-          <a:xfrm>
-            <a:off x="8412480" y="1656893"/>
+          <p:cNvPr id="17" name="Text 15"/>
+          <p:cNvSpPr/>
+          <p:nvPr/>
+        </p:nvSpPr>
+        <p:spPr>
+          <a:xfrm>
+            <a:off x="8412480" y="1976933"/>
             <a:ext cx="1371600" cy="329184"/>
           </a:xfrm>
           <a:prstGeom prst="rect">
@@ -11878,14 +12894,14 @@
       </p:sp>
       <p:sp>
         <p:nvSpPr>
-          <p:cNvPr id="17" name="Text 15"/>
-          <p:cNvSpPr/>
-          <p:nvPr/>
-        </p:nvSpPr>
-        <p:spPr>
-          <a:xfrm>
-            <a:off x="8412480" y="2148840"/>
-            <a:ext cx="3218688" cy="3291840"/>
+          <p:cNvPr id="18" name="Text 16"/>
+          <p:cNvSpPr/>
+          <p:nvPr/>
+        </p:nvSpPr>
+        <p:spPr>
+          <a:xfrm>
+            <a:off x="8412480" y="2468880"/>
+            <a:ext cx="3218688" cy="2971800"/>
           </a:xfrm>
           <a:prstGeom prst="rect">
             <a:avLst/>
@@ -11960,7 +12976,7 @@
       </p:sp>
       <p:sp>
         <p:nvSpPr>
-          <p:cNvPr id="18" name="Text 16"/>
+          <p:cNvPr id="19" name="Text 17"/>
           <p:cNvSpPr/>
           <p:nvPr/>
         </p:nvSpPr>
@@ -12218,7 +13234,7 @@
                 <a:ea typeface="Calibri" pitchFamily="34" charset="-122"/>
                 <a:cs typeface="Calibri" pitchFamily="34" charset="-120"/>
               </a:rPr>
-              <a:t>Responsable du matériel, sans en contrôler les outils : trois familles de girouettes, trois logiciels vendeurs verrouillés.</a:t>
+              <a:t>Aucune doc, des trames illisibles à 4800 bauds — jusqu'au soir où un glyphe deviné s'affiche sur le panneau : la géométrie était prouvée.</a:t>
             </a:r>
             <a:endParaRPr lang="en-US" sz="1350" dirty="0"/>
           </a:p>
@@ -12967,14 +13983,53 @@
       </p:sp>
       <p:sp>
         <p:nvSpPr>
-          <p:cNvPr id="6" name="Shape 4"/>
-          <p:cNvSpPr/>
-          <p:nvPr/>
-        </p:nvSpPr>
-        <p:spPr>
-          <a:xfrm>
-            <a:off x="502920" y="1463040"/>
-            <a:ext cx="3675888" cy="4160520"/>
+          <p:cNvPr id="6" name="Text 4"/>
+          <p:cNvSpPr/>
+          <p:nvPr/>
+        </p:nvSpPr>
+        <p:spPr>
+          <a:xfrm>
+            <a:off x="502920" y="1298448"/>
+            <a:ext cx="11155680" cy="457200"/>
+          </a:xfrm>
+          <a:prstGeom prst="rect">
+            <a:avLst/>
+          </a:prstGeom>
+          <a:noFill/>
+          <a:ln/>
+        </p:spPr>
+        <p:txBody>
+          <a:bodyPr wrap="square" lIns="0" tIns="0" rIns="0" bIns="0" rtlCol="0" anchor="ctr"/>
+          <a:lstStyle/>
+          <a:p>
+            <a:pPr indent="0" marL="0">
+              <a:buNone/>
+            </a:pPr>
+            <a:r>
+              <a:rPr lang="en-US" sz="1350" dirty="0">
+                <a:solidFill>
+                  <a:srgbClr val="9DB2C7"/>
+                </a:solidFill>
+                <a:latin typeface="Calibri" pitchFamily="34" charset="0"/>
+                <a:ea typeface="Calibri" pitchFamily="34" charset="-122"/>
+                <a:cs typeface="Calibri" pitchFamily="34" charset="-120"/>
+              </a:rPr>
+              <a:t>Pendant que l'équipe dort, l'établi travaille : une caméra juge chaque essai, et le matin, la réponse attend.</a:t>
+            </a:r>
+            <a:endParaRPr lang="en-US" sz="1350" dirty="0"/>
+          </a:p>
+        </p:txBody>
+      </p:sp>
+      <p:sp>
+        <p:nvSpPr>
+          <p:cNvPr id="7" name="Shape 5"/>
+          <p:cNvSpPr/>
+          <p:nvPr/>
+        </p:nvSpPr>
+        <p:spPr>
+          <a:xfrm>
+            <a:off x="502920" y="1783080"/>
+            <a:ext cx="3675888" cy="3840480"/>
           </a:xfrm>
           <a:prstGeom prst="roundRect">
             <a:avLst>
@@ -12994,13 +14049,13 @@
       </p:sp>
       <p:sp>
         <p:nvSpPr>
-          <p:cNvPr id="7" name="Shape 5"/>
-          <p:cNvSpPr/>
-          <p:nvPr/>
-        </p:nvSpPr>
-        <p:spPr>
-          <a:xfrm>
-            <a:off x="731520" y="1664208"/>
+          <p:cNvPr id="8" name="Shape 6"/>
+          <p:cNvSpPr/>
+          <p:nvPr/>
+        </p:nvSpPr>
+        <p:spPr>
+          <a:xfrm>
+            <a:off x="731520" y="1984248"/>
             <a:ext cx="1371600" cy="310896"/>
           </a:xfrm>
           <a:prstGeom prst="roundRect">
@@ -13016,13 +14071,13 @@
       </p:sp>
       <p:sp>
         <p:nvSpPr>
-          <p:cNvPr id="8" name="Text 6"/>
-          <p:cNvSpPr/>
-          <p:nvPr/>
-        </p:nvSpPr>
-        <p:spPr>
-          <a:xfrm>
-            <a:off x="731520" y="1656893"/>
+          <p:cNvPr id="9" name="Text 7"/>
+          <p:cNvSpPr/>
+          <p:nvPr/>
+        </p:nvSpPr>
+        <p:spPr>
+          <a:xfrm>
+            <a:off x="731520" y="1976933"/>
             <a:ext cx="1371600" cy="329184"/>
           </a:xfrm>
           <a:prstGeom prst="rect">
@@ -13055,14 +14110,14 @@
       </p:sp>
       <p:sp>
         <p:nvSpPr>
-          <p:cNvPr id="9" name="Text 7"/>
-          <p:cNvSpPr/>
-          <p:nvPr/>
-        </p:nvSpPr>
-        <p:spPr>
-          <a:xfrm>
-            <a:off x="731520" y="2148840"/>
-            <a:ext cx="3218688" cy="3291840"/>
+          <p:cNvPr id="10" name="Text 8"/>
+          <p:cNvSpPr/>
+          <p:nvPr/>
+        </p:nvSpPr>
+        <p:spPr>
+          <a:xfrm>
+            <a:off x="731520" y="2468880"/>
+            <a:ext cx="3218688" cy="2971800"/>
           </a:xfrm>
           <a:prstGeom prst="rect">
             <a:avLst/>
@@ -13117,14 +14172,14 @@
       </p:sp>
       <p:sp>
         <p:nvSpPr>
-          <p:cNvPr id="10" name="Shape 8"/>
-          <p:cNvSpPr/>
-          <p:nvPr/>
-        </p:nvSpPr>
-        <p:spPr>
-          <a:xfrm>
-            <a:off x="4343400" y="1463040"/>
-            <a:ext cx="3675888" cy="4160520"/>
+          <p:cNvPr id="11" name="Shape 9"/>
+          <p:cNvSpPr/>
+          <p:nvPr/>
+        </p:nvSpPr>
+        <p:spPr>
+          <a:xfrm>
+            <a:off x="4343400" y="1783080"/>
+            <a:ext cx="3675888" cy="3840480"/>
           </a:xfrm>
           <a:prstGeom prst="roundRect">
             <a:avLst>
@@ -13144,13 +14199,13 @@
       </p:sp>
       <p:sp>
         <p:nvSpPr>
-          <p:cNvPr id="11" name="Shape 9"/>
-          <p:cNvSpPr/>
-          <p:nvPr/>
-        </p:nvSpPr>
-        <p:spPr>
-          <a:xfrm>
-            <a:off x="4572000" y="1664208"/>
+          <p:cNvPr id="12" name="Shape 10"/>
+          <p:cNvSpPr/>
+          <p:nvPr/>
+        </p:nvSpPr>
+        <p:spPr>
+          <a:xfrm>
+            <a:off x="4572000" y="1984248"/>
             <a:ext cx="1371600" cy="310896"/>
           </a:xfrm>
           <a:prstGeom prst="roundRect">
@@ -13166,13 +14221,13 @@
       </p:sp>
       <p:sp>
         <p:nvSpPr>
-          <p:cNvPr id="12" name="Text 10"/>
-          <p:cNvSpPr/>
-          <p:nvPr/>
-        </p:nvSpPr>
-        <p:spPr>
-          <a:xfrm>
-            <a:off x="4572000" y="1656893"/>
+          <p:cNvPr id="13" name="Text 11"/>
+          <p:cNvSpPr/>
+          <p:nvPr/>
+        </p:nvSpPr>
+        <p:spPr>
+          <a:xfrm>
+            <a:off x="4572000" y="1976933"/>
             <a:ext cx="1371600" cy="329184"/>
           </a:xfrm>
           <a:prstGeom prst="rect">
@@ -13205,14 +14260,14 @@
       </p:sp>
       <p:sp>
         <p:nvSpPr>
-          <p:cNvPr id="13" name="Text 11"/>
-          <p:cNvSpPr/>
-          <p:nvPr/>
-        </p:nvSpPr>
-        <p:spPr>
-          <a:xfrm>
-            <a:off x="4572000" y="2148840"/>
-            <a:ext cx="3218688" cy="3291840"/>
+          <p:cNvPr id="14" name="Text 12"/>
+          <p:cNvSpPr/>
+          <p:nvPr/>
+        </p:nvSpPr>
+        <p:spPr>
+          <a:xfrm>
+            <a:off x="4572000" y="2468880"/>
+            <a:ext cx="3218688" cy="2971800"/>
           </a:xfrm>
           <a:prstGeom prst="rect">
             <a:avLst/>
@@ -13267,14 +14322,14 @@
       </p:sp>
       <p:sp>
         <p:nvSpPr>
-          <p:cNvPr id="14" name="Shape 12"/>
-          <p:cNvSpPr/>
-          <p:nvPr/>
-        </p:nvSpPr>
-        <p:spPr>
-          <a:xfrm>
-            <a:off x="8183880" y="1463040"/>
-            <a:ext cx="3675888" cy="4160520"/>
+          <p:cNvPr id="15" name="Shape 13"/>
+          <p:cNvSpPr/>
+          <p:nvPr/>
+        </p:nvSpPr>
+        <p:spPr>
+          <a:xfrm>
+            <a:off x="8183880" y="1783080"/>
+            <a:ext cx="3675888" cy="3840480"/>
           </a:xfrm>
           <a:prstGeom prst="roundRect">
             <a:avLst>
@@ -13294,13 +14349,13 @@
       </p:sp>
       <p:sp>
         <p:nvSpPr>
-          <p:cNvPr id="15" name="Shape 13"/>
-          <p:cNvSpPr/>
-          <p:nvPr/>
-        </p:nvSpPr>
-        <p:spPr>
-          <a:xfrm>
-            <a:off x="8412480" y="1664208"/>
+          <p:cNvPr id="16" name="Shape 14"/>
+          <p:cNvSpPr/>
+          <p:nvPr/>
+        </p:nvSpPr>
+        <p:spPr>
+          <a:xfrm>
+            <a:off x="8412480" y="1984248"/>
             <a:ext cx="1371600" cy="310896"/>
           </a:xfrm>
           <a:prstGeom prst="roundRect">
@@ -13316,13 +14371,13 @@
       </p:sp>
       <p:sp>
         <p:nvSpPr>
-          <p:cNvPr id="16" name="Text 14"/>
-          <p:cNvSpPr/>
-          <p:nvPr/>
-        </p:nvSpPr>
-        <p:spPr>
-          <a:xfrm>
-            <a:off x="8412480" y="1656893"/>
+          <p:cNvPr id="17" name="Text 15"/>
+          <p:cNvSpPr/>
+          <p:nvPr/>
+        </p:nvSpPr>
+        <p:spPr>
+          <a:xfrm>
+            <a:off x="8412480" y="1976933"/>
             <a:ext cx="1371600" cy="329184"/>
           </a:xfrm>
           <a:prstGeom prst="rect">
@@ -13355,14 +14410,14 @@
       </p:sp>
       <p:sp>
         <p:nvSpPr>
-          <p:cNvPr id="17" name="Text 15"/>
-          <p:cNvSpPr/>
-          <p:nvPr/>
-        </p:nvSpPr>
-        <p:spPr>
-          <a:xfrm>
-            <a:off x="8412480" y="2148840"/>
-            <a:ext cx="3218688" cy="3291840"/>
+          <p:cNvPr id="18" name="Text 16"/>
+          <p:cNvSpPr/>
+          <p:nvPr/>
+        </p:nvSpPr>
+        <p:spPr>
+          <a:xfrm>
+            <a:off x="8412480" y="2468880"/>
+            <a:ext cx="3218688" cy="2971800"/>
           </a:xfrm>
           <a:prstGeom prst="rect">
             <a:avLst/>
@@ -13437,7 +14492,7 @@
       </p:sp>
       <p:sp>
         <p:nvSpPr>
-          <p:cNvPr id="18" name="Text 16"/>
+          <p:cNvPr id="19" name="Text 17"/>
           <p:cNvSpPr/>
           <p:nvPr/>
         </p:nvSpPr>

</xml_diff>